<commit_message>
test(e2e): verify staged builds + animClr playback across all five bindings
Regenerate the fixture with slide-title + shape-text anchors and add a Playwright spec (runs per-binding in CI) asserting the chart build entrance plays and the fill-colour emphasis animates. Verified locally: 10/10 across react, vue, angular, svelte, vanilla.

Co-Authored-By: Claude Opus 4.8 (1M context) <noreply@anthropic.com>
Claude-Session: https://claude.ai/code/session_014gVRSGZouaLWRbPBPKeqs5
</commit_message>
<xml_diff>
--- a/e2e/fixtures/animation-builds-color.pptx
+++ b/e2e/fixtures/animation-builds-color.pptx
@@ -197,7 +197,7 @@
           </c:val>
           <c:extLst>
             <c:ext xmlns:c16="http://schemas.microsoft.com/office/drawing/2014/chart" uri="{C3380CC4-5D6E-409C-BE32-E72D297353CC}">
-              <c16:uniqueId val="{00000000-2DC7-46B4-BD79-CDC5457E2E54}"/>
+              <c16:uniqueId val="{00000000-D7FA-49AD-9F88-FFE60A693B44}"/>
             </c:ext>
           </c:extLst>
         </c:ser>
@@ -268,7 +268,7 @@
           </c:val>
           <c:extLst>
             <c:ext xmlns:c16="http://schemas.microsoft.com/office/drawing/2014/chart" uri="{C3380CC4-5D6E-409C-BE32-E72D297353CC}">
-              <c16:uniqueId val="{00000001-2DC7-46B4-BD79-CDC5457E2E54}"/>
+              <c16:uniqueId val="{00000001-D7FA-49AD-9F88-FFE60A693B44}"/>
             </c:ext>
           </c:extLst>
         </c:ser>
@@ -339,7 +339,7 @@
           </c:val>
           <c:extLst>
             <c:ext xmlns:c16="http://schemas.microsoft.com/office/drawing/2014/chart" uri="{C3380CC4-5D6E-409C-BE32-E72D297353CC}">
-              <c16:uniqueId val="{00000002-2DC7-46B4-BD79-CDC5457E2E54}"/>
+              <c16:uniqueId val="{00000002-D7FA-49AD-9F88-FFE60A693B44}"/>
             </c:ext>
           </c:extLst>
         </c:ser>
@@ -353,11 +353,11 @@
         </c:dLbls>
         <c:gapWidth val="219"/>
         <c:overlap val="-27"/>
-        <c:axId val="473714928"/>
-        <c:axId val="473715408"/>
+        <c:axId val="492909264"/>
+        <c:axId val="1868226672"/>
       </c:barChart>
       <c:catAx>
-        <c:axId val="473714928"/>
+        <c:axId val="492909264"/>
         <c:scaling>
           <c:orientation val="minMax"/>
         </c:scaling>
@@ -400,7 +400,7 @@
             <a:endParaRPr lang="en-US"/>
           </a:p>
         </c:txPr>
-        <c:crossAx val="473715408"/>
+        <c:crossAx val="1868226672"/>
         <c:crosses val="autoZero"/>
         <c:auto val="1"/>
         <c:lblAlgn val="ctr"/>
@@ -408,7 +408,7 @@
         <c:noMultiLvlLbl val="0"/>
       </c:catAx>
       <c:valAx>
-        <c:axId val="473715408"/>
+        <c:axId val="1868226672"/>
         <c:scaling>
           <c:orientation val="minMax"/>
         </c:scaling>
@@ -459,7 +459,7 @@
             <a:endParaRPr lang="en-US"/>
           </a:p>
         </c:txPr>
-        <c:crossAx val="473714928"/>
+        <c:crossAx val="492909264"/>
         <c:crosses val="autoZero"/>
         <c:crossBetween val="between"/>
       </c:valAx>
@@ -1829,7 +1829,7 @@
 <file path=ppt/diagrams/data1.xml><?xml version="1.0" encoding="utf-8"?>
 <dgm:dataModel xmlns:dgm="http://schemas.openxmlformats.org/drawingml/2006/diagram" xmlns:a="http://schemas.openxmlformats.org/drawingml/2006/main">
   <dgm:ptLst>
-    <dgm:pt modelId="{4811B8FD-B393-484F-8C16-0316903B9BC0}" type="doc">
+    <dgm:pt modelId="{1FE7E047-0A11-4029-BFF1-CC67C2FD8B9C}" type="doc">
       <dgm:prSet loTypeId="urn:microsoft.com/office/officeart/2005/8/layout/default" loCatId="list" qsTypeId="urn:microsoft.com/office/officeart/2005/8/quickstyle/simple1" qsCatId="simple" csTypeId="urn:microsoft.com/office/officeart/2005/8/colors/accent1_2" csCatId="accent1" phldr="0"/>
       <dgm:spPr/>
       <dgm:t>
@@ -1840,7 +1840,7 @@
         </a:p>
       </dgm:t>
     </dgm:pt>
-    <dgm:pt modelId="{66015F1C-A06D-4AFB-B52C-F7030C9C7302}">
+    <dgm:pt modelId="{0226E201-763C-4284-8D00-F8E7764E6732}">
       <dgm:prSet phldrT="[Text]" phldr="1"/>
       <dgm:spPr/>
       <dgm:t>
@@ -1851,7 +1851,7 @@
         </a:p>
       </dgm:t>
     </dgm:pt>
-    <dgm:pt modelId="{2802E225-D7C2-4C20-B256-362C94D0D711}" type="parTrans" cxnId="{AF4C0F66-BA81-4F52-A989-F44D82FEC94A}">
+    <dgm:pt modelId="{057F5208-2115-44B4-BD2A-72CF27E4BE66}" type="parTrans" cxnId="{995AF60E-1FA5-4FA9-B79E-97F9EA180FB6}">
       <dgm:prSet/>
       <dgm:spPr/>
       <dgm:t>
@@ -1862,7 +1862,7 @@
         </a:p>
       </dgm:t>
     </dgm:pt>
-    <dgm:pt modelId="{B9709B9F-1E3B-424A-8157-3888E6E74863}" type="sibTrans" cxnId="{AF4C0F66-BA81-4F52-A989-F44D82FEC94A}">
+    <dgm:pt modelId="{C4D968BC-BB41-4D64-A341-49AA3C4D3F21}" type="sibTrans" cxnId="{995AF60E-1FA5-4FA9-B79E-97F9EA180FB6}">
       <dgm:prSet/>
       <dgm:spPr/>
       <dgm:t>
@@ -1873,7 +1873,7 @@
         </a:p>
       </dgm:t>
     </dgm:pt>
-    <dgm:pt modelId="{EDA46707-1D71-41F4-907F-563BBB539505}">
+    <dgm:pt modelId="{B2532C47-25A1-46FC-8A6C-8BF26FA64D1E}">
       <dgm:prSet phldrT="[Text]" phldr="1"/>
       <dgm:spPr/>
       <dgm:t>
@@ -1884,7 +1884,7 @@
         </a:p>
       </dgm:t>
     </dgm:pt>
-    <dgm:pt modelId="{D612F926-0416-488B-A94F-25E918259D1A}" type="parTrans" cxnId="{63B53067-E6FC-44C9-9369-9A34A5A26A3A}">
+    <dgm:pt modelId="{CD025766-524B-4941-96D6-3452368D1989}" type="parTrans" cxnId="{0EBEA0D2-FB11-4AA2-8E74-B7C86D4CFFC8}">
       <dgm:prSet/>
       <dgm:spPr/>
       <dgm:t>
@@ -1895,7 +1895,7 @@
         </a:p>
       </dgm:t>
     </dgm:pt>
-    <dgm:pt modelId="{6F32E159-A429-4EC2-B37B-5740AF31571B}" type="sibTrans" cxnId="{63B53067-E6FC-44C9-9369-9A34A5A26A3A}">
+    <dgm:pt modelId="{A6AC9869-374E-4700-A74A-7912B465E45A}" type="sibTrans" cxnId="{0EBEA0D2-FB11-4AA2-8E74-B7C86D4CFFC8}">
       <dgm:prSet/>
       <dgm:spPr/>
       <dgm:t>
@@ -1906,7 +1906,7 @@
         </a:p>
       </dgm:t>
     </dgm:pt>
-    <dgm:pt modelId="{2BCC80D9-77B4-47C7-9F45-360F6E9CB3AE}">
+    <dgm:pt modelId="{A90A660D-F572-43F2-B768-6E837FA3726A}">
       <dgm:prSet phldrT="[Text]" phldr="1"/>
       <dgm:spPr/>
       <dgm:t>
@@ -1917,7 +1917,7 @@
         </a:p>
       </dgm:t>
     </dgm:pt>
-    <dgm:pt modelId="{46900669-74FD-41FB-A67A-F8AF7DAA6346}" type="parTrans" cxnId="{9A85755E-A593-4DB2-8195-DE3B4F8A0AB2}">
+    <dgm:pt modelId="{25C7ACAB-4C4E-4CB3-B3B0-2E6A23D34692}" type="parTrans" cxnId="{DF0E7ADA-7418-40F3-837B-C79F885AAA70}">
       <dgm:prSet/>
       <dgm:spPr/>
       <dgm:t>
@@ -1928,7 +1928,7 @@
         </a:p>
       </dgm:t>
     </dgm:pt>
-    <dgm:pt modelId="{3BDC5993-AC18-4587-819A-76354D9EC3FB}" type="sibTrans" cxnId="{9A85755E-A593-4DB2-8195-DE3B4F8A0AB2}">
+    <dgm:pt modelId="{479911EE-8740-498C-9130-23814B2EE6A1}" type="sibTrans" cxnId="{DF0E7ADA-7418-40F3-837B-C79F885AAA70}">
       <dgm:prSet/>
       <dgm:spPr/>
       <dgm:t>
@@ -1939,7 +1939,7 @@
         </a:p>
       </dgm:t>
     </dgm:pt>
-    <dgm:pt modelId="{96C4CA0E-0580-439D-AADC-3A284C2BCDAE}">
+    <dgm:pt modelId="{E16A678E-571D-4A67-8A48-67E9D8919621}">
       <dgm:prSet phldrT="[Text]" phldr="1"/>
       <dgm:spPr/>
       <dgm:t>
@@ -1950,7 +1950,7 @@
         </a:p>
       </dgm:t>
     </dgm:pt>
-    <dgm:pt modelId="{43A27C03-8412-4D09-B4A2-AF63B7E1EDA0}" type="parTrans" cxnId="{A24EE360-71F8-4C4F-9E5F-5EE4AB382ADC}">
+    <dgm:pt modelId="{366DDF70-AAEE-4F6C-A65E-1CA841E9BD2A}" type="parTrans" cxnId="{CC4892A7-AB23-40F4-8100-ED9CF2E8B375}">
       <dgm:prSet/>
       <dgm:spPr/>
       <dgm:t>
@@ -1961,7 +1961,7 @@
         </a:p>
       </dgm:t>
     </dgm:pt>
-    <dgm:pt modelId="{2DAA5A03-AF29-4944-8354-B18DCD3E5AF2}" type="sibTrans" cxnId="{A24EE360-71F8-4C4F-9E5F-5EE4AB382ADC}">
+    <dgm:pt modelId="{82E08AE6-05CE-4A10-AD6D-0D1396AB42E8}" type="sibTrans" cxnId="{CC4892A7-AB23-40F4-8100-ED9CF2E8B375}">
       <dgm:prSet/>
       <dgm:spPr/>
       <dgm:t>
@@ -1972,7 +1972,7 @@
         </a:p>
       </dgm:t>
     </dgm:pt>
-    <dgm:pt modelId="{1D926448-8381-40E1-88BB-0237B8D9FA5D}">
+    <dgm:pt modelId="{018750A5-CF6C-4FF2-A71F-6E28429C8CD5}">
       <dgm:prSet phldrT="[Text]" phldr="1"/>
       <dgm:spPr/>
       <dgm:t>
@@ -1983,7 +1983,7 @@
         </a:p>
       </dgm:t>
     </dgm:pt>
-    <dgm:pt modelId="{0094F182-6AAB-40BF-8A37-845917E7740C}" type="parTrans" cxnId="{5982ADBE-B7EC-41AF-92F7-8458764F2576}">
+    <dgm:pt modelId="{A3C03C39-E677-4DEE-995E-796A2C9D7942}" type="parTrans" cxnId="{065E29CC-4124-4A74-B309-B1BB8C6BB6A8}">
       <dgm:prSet/>
       <dgm:spPr/>
       <dgm:t>
@@ -1994,7 +1994,7 @@
         </a:p>
       </dgm:t>
     </dgm:pt>
-    <dgm:pt modelId="{4A37188D-4482-4531-AF8C-38C592D21527}" type="sibTrans" cxnId="{5982ADBE-B7EC-41AF-92F7-8458764F2576}">
+    <dgm:pt modelId="{6CBB37D4-E449-46BD-8D51-D42FDFA3FCCE}" type="sibTrans" cxnId="{065E29CC-4124-4A74-B309-B1BB8C6BB6A8}">
       <dgm:prSet/>
       <dgm:spPr/>
       <dgm:t>
@@ -2005,8 +2005,8 @@
         </a:p>
       </dgm:t>
     </dgm:pt>
-    <dgm:pt modelId="{2DF7A4A5-7E33-4F33-9E38-0EA64C0A56A8}" type="pres">
-      <dgm:prSet presAssocID="{4811B8FD-B393-484F-8C16-0316903B9BC0}" presName="diagram" presStyleCnt="0">
+    <dgm:pt modelId="{DCB7562D-B22F-443D-80B2-3E111F6806C6}" type="pres">
+      <dgm:prSet presAssocID="{1FE7E047-0A11-4029-BFF1-CC67C2FD8B9C}" presName="diagram" presStyleCnt="0">
         <dgm:presLayoutVars>
           <dgm:dir/>
           <dgm:resizeHandles val="exact"/>
@@ -2014,56 +2014,56 @@
       </dgm:prSet>
       <dgm:spPr/>
     </dgm:pt>
-    <dgm:pt modelId="{A63750CF-CF92-4612-BE76-0B0FFC57B29F}" type="pres">
-      <dgm:prSet presAssocID="{66015F1C-A06D-4AFB-B52C-F7030C9C7302}" presName="node" presStyleLbl="node1" presStyleIdx="0" presStyleCnt="5">
+    <dgm:pt modelId="{1F55CCF8-CF93-4880-A199-6B92E47F3C72}" type="pres">
+      <dgm:prSet presAssocID="{0226E201-763C-4284-8D00-F8E7764E6732}" presName="node" presStyleLbl="node1" presStyleIdx="0" presStyleCnt="5">
         <dgm:presLayoutVars>
           <dgm:bulletEnabled val="1"/>
         </dgm:presLayoutVars>
       </dgm:prSet>
       <dgm:spPr/>
     </dgm:pt>
-    <dgm:pt modelId="{586FDD23-0BD0-40A6-AADB-D90F8E679610}" type="pres">
-      <dgm:prSet presAssocID="{B9709B9F-1E3B-424A-8157-3888E6E74863}" presName="sibTrans" presStyleCnt="0"/>
+    <dgm:pt modelId="{003DEC4D-D9FA-41DB-8296-03C01CD62CFC}" type="pres">
+      <dgm:prSet presAssocID="{C4D968BC-BB41-4D64-A341-49AA3C4D3F21}" presName="sibTrans" presStyleCnt="0"/>
       <dgm:spPr/>
     </dgm:pt>
-    <dgm:pt modelId="{1B23FE2D-A12E-42DF-8E10-EB2DBB93FF5F}" type="pres">
-      <dgm:prSet presAssocID="{EDA46707-1D71-41F4-907F-563BBB539505}" presName="node" presStyleLbl="node1" presStyleIdx="1" presStyleCnt="5">
+    <dgm:pt modelId="{AEFEFF65-2B6B-49AD-9BBE-F69ADBC409B3}" type="pres">
+      <dgm:prSet presAssocID="{B2532C47-25A1-46FC-8A6C-8BF26FA64D1E}" presName="node" presStyleLbl="node1" presStyleIdx="1" presStyleCnt="5">
         <dgm:presLayoutVars>
           <dgm:bulletEnabled val="1"/>
         </dgm:presLayoutVars>
       </dgm:prSet>
       <dgm:spPr/>
     </dgm:pt>
-    <dgm:pt modelId="{C8CF4AB8-A15E-44BA-B7F9-E6957524DCD1}" type="pres">
-      <dgm:prSet presAssocID="{6F32E159-A429-4EC2-B37B-5740AF31571B}" presName="sibTrans" presStyleCnt="0"/>
+    <dgm:pt modelId="{D03D1E8F-6B05-4BB6-A15E-D34045A7785D}" type="pres">
+      <dgm:prSet presAssocID="{A6AC9869-374E-4700-A74A-7912B465E45A}" presName="sibTrans" presStyleCnt="0"/>
       <dgm:spPr/>
     </dgm:pt>
-    <dgm:pt modelId="{29E9B170-CB20-4F37-8D80-CB70BB392088}" type="pres">
-      <dgm:prSet presAssocID="{2BCC80D9-77B4-47C7-9F45-360F6E9CB3AE}" presName="node" presStyleLbl="node1" presStyleIdx="2" presStyleCnt="5">
+    <dgm:pt modelId="{B0076D32-3A80-4DFE-BFB6-E5115B4588E3}" type="pres">
+      <dgm:prSet presAssocID="{A90A660D-F572-43F2-B768-6E837FA3726A}" presName="node" presStyleLbl="node1" presStyleIdx="2" presStyleCnt="5">
         <dgm:presLayoutVars>
           <dgm:bulletEnabled val="1"/>
         </dgm:presLayoutVars>
       </dgm:prSet>
       <dgm:spPr/>
     </dgm:pt>
-    <dgm:pt modelId="{D5FB83BF-645D-48D8-AA1D-9D5B0ED27CE5}" type="pres">
-      <dgm:prSet presAssocID="{3BDC5993-AC18-4587-819A-76354D9EC3FB}" presName="sibTrans" presStyleCnt="0"/>
+    <dgm:pt modelId="{881577AA-6CE0-4300-94FD-7EB927A517FF}" type="pres">
+      <dgm:prSet presAssocID="{479911EE-8740-498C-9130-23814B2EE6A1}" presName="sibTrans" presStyleCnt="0"/>
       <dgm:spPr/>
     </dgm:pt>
-    <dgm:pt modelId="{83BCF00E-6EA6-41C0-83D9-295109D26297}" type="pres">
-      <dgm:prSet presAssocID="{96C4CA0E-0580-439D-AADC-3A284C2BCDAE}" presName="node" presStyleLbl="node1" presStyleIdx="3" presStyleCnt="5">
+    <dgm:pt modelId="{7FBE29A4-D366-46F2-B3C5-355DE09CA2CF}" type="pres">
+      <dgm:prSet presAssocID="{E16A678E-571D-4A67-8A48-67E9D8919621}" presName="node" presStyleLbl="node1" presStyleIdx="3" presStyleCnt="5">
         <dgm:presLayoutVars>
           <dgm:bulletEnabled val="1"/>
         </dgm:presLayoutVars>
       </dgm:prSet>
       <dgm:spPr/>
     </dgm:pt>
-    <dgm:pt modelId="{7F446A06-DF6A-4B79-836F-057EE76D1A42}" type="pres">
-      <dgm:prSet presAssocID="{2DAA5A03-AF29-4944-8354-B18DCD3E5AF2}" presName="sibTrans" presStyleCnt="0"/>
+    <dgm:pt modelId="{AB4F864A-6E41-461B-83FC-FD59F4AE7E2D}" type="pres">
+      <dgm:prSet presAssocID="{82E08AE6-05CE-4A10-AD6D-0D1396AB42E8}" presName="sibTrans" presStyleCnt="0"/>
       <dgm:spPr/>
     </dgm:pt>
-    <dgm:pt modelId="{F29CF895-B683-4FFD-B5E7-E9B1CFD72E2F}" type="pres">
-      <dgm:prSet presAssocID="{1D926448-8381-40E1-88BB-0237B8D9FA5D}" presName="node" presStyleLbl="node1" presStyleIdx="4" presStyleCnt="5">
+    <dgm:pt modelId="{4143995B-ECD7-45B9-B0BE-9FFB5719AB3D}" type="pres">
+      <dgm:prSet presAssocID="{018750A5-CF6C-4FF2-A71F-6E28429C8CD5}" presName="node" presStyleLbl="node1" presStyleIdx="4" presStyleCnt="5">
         <dgm:presLayoutVars>
           <dgm:bulletEnabled val="1"/>
         </dgm:presLayoutVars>
@@ -2072,26 +2072,26 @@
     </dgm:pt>
   </dgm:ptLst>
   <dgm:cxnLst>
-    <dgm:cxn modelId="{3F3A8721-6D2C-4FDF-A59D-AB115A69008E}" type="presOf" srcId="{96C4CA0E-0580-439D-AADC-3A284C2BCDAE}" destId="{83BCF00E-6EA6-41C0-83D9-295109D26297}" srcOrd="0" destOrd="0" presId="urn:microsoft.com/office/officeart/2005/8/layout/default"/>
-    <dgm:cxn modelId="{9A85755E-A593-4DB2-8195-DE3B4F8A0AB2}" srcId="{4811B8FD-B393-484F-8C16-0316903B9BC0}" destId="{2BCC80D9-77B4-47C7-9F45-360F6E9CB3AE}" srcOrd="2" destOrd="0" parTransId="{46900669-74FD-41FB-A67A-F8AF7DAA6346}" sibTransId="{3BDC5993-AC18-4587-819A-76354D9EC3FB}"/>
-    <dgm:cxn modelId="{A24EE360-71F8-4C4F-9E5F-5EE4AB382ADC}" srcId="{4811B8FD-B393-484F-8C16-0316903B9BC0}" destId="{96C4CA0E-0580-439D-AADC-3A284C2BCDAE}" srcOrd="3" destOrd="0" parTransId="{43A27C03-8412-4D09-B4A2-AF63B7E1EDA0}" sibTransId="{2DAA5A03-AF29-4944-8354-B18DCD3E5AF2}"/>
-    <dgm:cxn modelId="{AF4C0F66-BA81-4F52-A989-F44D82FEC94A}" srcId="{4811B8FD-B393-484F-8C16-0316903B9BC0}" destId="{66015F1C-A06D-4AFB-B52C-F7030C9C7302}" srcOrd="0" destOrd="0" parTransId="{2802E225-D7C2-4C20-B256-362C94D0D711}" sibTransId="{B9709B9F-1E3B-424A-8157-3888E6E74863}"/>
-    <dgm:cxn modelId="{08D37866-F082-4E9E-BCF9-52EE1D38F97F}" type="presOf" srcId="{2BCC80D9-77B4-47C7-9F45-360F6E9CB3AE}" destId="{29E9B170-CB20-4F37-8D80-CB70BB392088}" srcOrd="0" destOrd="0" presId="urn:microsoft.com/office/officeart/2005/8/layout/default"/>
-    <dgm:cxn modelId="{63B53067-E6FC-44C9-9369-9A34A5A26A3A}" srcId="{4811B8FD-B393-484F-8C16-0316903B9BC0}" destId="{EDA46707-1D71-41F4-907F-563BBB539505}" srcOrd="1" destOrd="0" parTransId="{D612F926-0416-488B-A94F-25E918259D1A}" sibTransId="{6F32E159-A429-4EC2-B37B-5740AF31571B}"/>
-    <dgm:cxn modelId="{7E885455-5D97-4E52-A423-E31AE5DE4F69}" type="presOf" srcId="{EDA46707-1D71-41F4-907F-563BBB539505}" destId="{1B23FE2D-A12E-42DF-8E10-EB2DBB93FF5F}" srcOrd="0" destOrd="0" presId="urn:microsoft.com/office/officeart/2005/8/layout/default"/>
-    <dgm:cxn modelId="{BA26DA99-5072-4D09-ADB4-F96049E43C53}" type="presOf" srcId="{4811B8FD-B393-484F-8C16-0316903B9BC0}" destId="{2DF7A4A5-7E33-4F33-9E38-0EA64C0A56A8}" srcOrd="0" destOrd="0" presId="urn:microsoft.com/office/officeart/2005/8/layout/default"/>
-    <dgm:cxn modelId="{5982ADBE-B7EC-41AF-92F7-8458764F2576}" srcId="{4811B8FD-B393-484F-8C16-0316903B9BC0}" destId="{1D926448-8381-40E1-88BB-0237B8D9FA5D}" srcOrd="4" destOrd="0" parTransId="{0094F182-6AAB-40BF-8A37-845917E7740C}" sibTransId="{4A37188D-4482-4531-AF8C-38C592D21527}"/>
-    <dgm:cxn modelId="{DD33C1DE-3815-4D9B-AF91-A619E3413D26}" type="presOf" srcId="{66015F1C-A06D-4AFB-B52C-F7030C9C7302}" destId="{A63750CF-CF92-4612-BE76-0B0FFC57B29F}" srcOrd="0" destOrd="0" presId="urn:microsoft.com/office/officeart/2005/8/layout/default"/>
-    <dgm:cxn modelId="{61DCBAE9-63E5-4472-8108-1CBA91B05D02}" type="presOf" srcId="{1D926448-8381-40E1-88BB-0237B8D9FA5D}" destId="{F29CF895-B683-4FFD-B5E7-E9B1CFD72E2F}" srcOrd="0" destOrd="0" presId="urn:microsoft.com/office/officeart/2005/8/layout/default"/>
-    <dgm:cxn modelId="{C07286E2-7125-4863-BA62-6429F875346B}" type="presParOf" srcId="{2DF7A4A5-7E33-4F33-9E38-0EA64C0A56A8}" destId="{A63750CF-CF92-4612-BE76-0B0FFC57B29F}" srcOrd="0" destOrd="0" presId="urn:microsoft.com/office/officeart/2005/8/layout/default"/>
-    <dgm:cxn modelId="{0D44B907-4599-4E6D-82E6-B1A1B6C13C25}" type="presParOf" srcId="{2DF7A4A5-7E33-4F33-9E38-0EA64C0A56A8}" destId="{586FDD23-0BD0-40A6-AADB-D90F8E679610}" srcOrd="1" destOrd="0" presId="urn:microsoft.com/office/officeart/2005/8/layout/default"/>
-    <dgm:cxn modelId="{A75E4C73-3712-4E28-A770-87A6E02F73A4}" type="presParOf" srcId="{2DF7A4A5-7E33-4F33-9E38-0EA64C0A56A8}" destId="{1B23FE2D-A12E-42DF-8E10-EB2DBB93FF5F}" srcOrd="2" destOrd="0" presId="urn:microsoft.com/office/officeart/2005/8/layout/default"/>
-    <dgm:cxn modelId="{785CE89C-898A-491D-9FD5-459D5C6F6248}" type="presParOf" srcId="{2DF7A4A5-7E33-4F33-9E38-0EA64C0A56A8}" destId="{C8CF4AB8-A15E-44BA-B7F9-E6957524DCD1}" srcOrd="3" destOrd="0" presId="urn:microsoft.com/office/officeart/2005/8/layout/default"/>
-    <dgm:cxn modelId="{6D272137-9C72-4390-8929-F5F998F4715C}" type="presParOf" srcId="{2DF7A4A5-7E33-4F33-9E38-0EA64C0A56A8}" destId="{29E9B170-CB20-4F37-8D80-CB70BB392088}" srcOrd="4" destOrd="0" presId="urn:microsoft.com/office/officeart/2005/8/layout/default"/>
-    <dgm:cxn modelId="{3C5C0D2E-F8D7-4E03-808D-98C808485793}" type="presParOf" srcId="{2DF7A4A5-7E33-4F33-9E38-0EA64C0A56A8}" destId="{D5FB83BF-645D-48D8-AA1D-9D5B0ED27CE5}" srcOrd="5" destOrd="0" presId="urn:microsoft.com/office/officeart/2005/8/layout/default"/>
-    <dgm:cxn modelId="{C85C45A3-0C3C-4A1E-85DE-6A6A2ED79147}" type="presParOf" srcId="{2DF7A4A5-7E33-4F33-9E38-0EA64C0A56A8}" destId="{83BCF00E-6EA6-41C0-83D9-295109D26297}" srcOrd="6" destOrd="0" presId="urn:microsoft.com/office/officeart/2005/8/layout/default"/>
-    <dgm:cxn modelId="{0089C5D3-11B3-42B3-8FB4-415F1545DB44}" type="presParOf" srcId="{2DF7A4A5-7E33-4F33-9E38-0EA64C0A56A8}" destId="{7F446A06-DF6A-4B79-836F-057EE76D1A42}" srcOrd="7" destOrd="0" presId="urn:microsoft.com/office/officeart/2005/8/layout/default"/>
-    <dgm:cxn modelId="{9FD1AA05-FE74-4BEE-86A4-658DDBE1E4DB}" type="presParOf" srcId="{2DF7A4A5-7E33-4F33-9E38-0EA64C0A56A8}" destId="{F29CF895-B683-4FFD-B5E7-E9B1CFD72E2F}" srcOrd="8" destOrd="0" presId="urn:microsoft.com/office/officeart/2005/8/layout/default"/>
+    <dgm:cxn modelId="{995AF60E-1FA5-4FA9-B79E-97F9EA180FB6}" srcId="{1FE7E047-0A11-4029-BFF1-CC67C2FD8B9C}" destId="{0226E201-763C-4284-8D00-F8E7764E6732}" srcOrd="0" destOrd="0" parTransId="{057F5208-2115-44B4-BD2A-72CF27E4BE66}" sibTransId="{C4D968BC-BB41-4D64-A341-49AA3C4D3F21}"/>
+    <dgm:cxn modelId="{4C113C27-D999-4513-B701-6554E982A4D5}" type="presOf" srcId="{B2532C47-25A1-46FC-8A6C-8BF26FA64D1E}" destId="{AEFEFF65-2B6B-49AD-9BBE-F69ADBC409B3}" srcOrd="0" destOrd="0" presId="urn:microsoft.com/office/officeart/2005/8/layout/default"/>
+    <dgm:cxn modelId="{D766846A-E27E-4304-939B-D1A688D94E80}" type="presOf" srcId="{E16A678E-571D-4A67-8A48-67E9D8919621}" destId="{7FBE29A4-D366-46F2-B3C5-355DE09CA2CF}" srcOrd="0" destOrd="0" presId="urn:microsoft.com/office/officeart/2005/8/layout/default"/>
+    <dgm:cxn modelId="{7EBE7578-FA58-42F6-8EBD-21B6A459B365}" type="presOf" srcId="{018750A5-CF6C-4FF2-A71F-6E28429C8CD5}" destId="{4143995B-ECD7-45B9-B0BE-9FFB5719AB3D}" srcOrd="0" destOrd="0" presId="urn:microsoft.com/office/officeart/2005/8/layout/default"/>
+    <dgm:cxn modelId="{70BF5C7A-9CBC-4E4B-9F90-74E34BE03073}" type="presOf" srcId="{0226E201-763C-4284-8D00-F8E7764E6732}" destId="{1F55CCF8-CF93-4880-A199-6B92E47F3C72}" srcOrd="0" destOrd="0" presId="urn:microsoft.com/office/officeart/2005/8/layout/default"/>
+    <dgm:cxn modelId="{8F8E54A2-FCB9-4543-8509-2B16F312CF31}" type="presOf" srcId="{1FE7E047-0A11-4029-BFF1-CC67C2FD8B9C}" destId="{DCB7562D-B22F-443D-80B2-3E111F6806C6}" srcOrd="0" destOrd="0" presId="urn:microsoft.com/office/officeart/2005/8/layout/default"/>
+    <dgm:cxn modelId="{CC4892A7-AB23-40F4-8100-ED9CF2E8B375}" srcId="{1FE7E047-0A11-4029-BFF1-CC67C2FD8B9C}" destId="{E16A678E-571D-4A67-8A48-67E9D8919621}" srcOrd="3" destOrd="0" parTransId="{366DDF70-AAEE-4F6C-A65E-1CA841E9BD2A}" sibTransId="{82E08AE6-05CE-4A10-AD6D-0D1396AB42E8}"/>
+    <dgm:cxn modelId="{065E29CC-4124-4A74-B309-B1BB8C6BB6A8}" srcId="{1FE7E047-0A11-4029-BFF1-CC67C2FD8B9C}" destId="{018750A5-CF6C-4FF2-A71F-6E28429C8CD5}" srcOrd="4" destOrd="0" parTransId="{A3C03C39-E677-4DEE-995E-796A2C9D7942}" sibTransId="{6CBB37D4-E449-46BD-8D51-D42FDFA3FCCE}"/>
+    <dgm:cxn modelId="{0EBEA0D2-FB11-4AA2-8E74-B7C86D4CFFC8}" srcId="{1FE7E047-0A11-4029-BFF1-CC67C2FD8B9C}" destId="{B2532C47-25A1-46FC-8A6C-8BF26FA64D1E}" srcOrd="1" destOrd="0" parTransId="{CD025766-524B-4941-96D6-3452368D1989}" sibTransId="{A6AC9869-374E-4700-A74A-7912B465E45A}"/>
+    <dgm:cxn modelId="{DF0E7ADA-7418-40F3-837B-C79F885AAA70}" srcId="{1FE7E047-0A11-4029-BFF1-CC67C2FD8B9C}" destId="{A90A660D-F572-43F2-B768-6E837FA3726A}" srcOrd="2" destOrd="0" parTransId="{25C7ACAB-4C4E-4CB3-B3B0-2E6A23D34692}" sibTransId="{479911EE-8740-498C-9130-23814B2EE6A1}"/>
+    <dgm:cxn modelId="{4DE600F5-BDCA-4FDB-A01E-E3D58192FDD8}" type="presOf" srcId="{A90A660D-F572-43F2-B768-6E837FA3726A}" destId="{B0076D32-3A80-4DFE-BFB6-E5115B4588E3}" srcOrd="0" destOrd="0" presId="urn:microsoft.com/office/officeart/2005/8/layout/default"/>
+    <dgm:cxn modelId="{829A1FC6-E62E-4851-AC6D-ADE6C921388F}" type="presParOf" srcId="{DCB7562D-B22F-443D-80B2-3E111F6806C6}" destId="{1F55CCF8-CF93-4880-A199-6B92E47F3C72}" srcOrd="0" destOrd="0" presId="urn:microsoft.com/office/officeart/2005/8/layout/default"/>
+    <dgm:cxn modelId="{1A36FFF5-52C0-42C8-B02E-401998BA679C}" type="presParOf" srcId="{DCB7562D-B22F-443D-80B2-3E111F6806C6}" destId="{003DEC4D-D9FA-41DB-8296-03C01CD62CFC}" srcOrd="1" destOrd="0" presId="urn:microsoft.com/office/officeart/2005/8/layout/default"/>
+    <dgm:cxn modelId="{CF817375-5D02-41CA-9C8C-D9BBF8439BA6}" type="presParOf" srcId="{DCB7562D-B22F-443D-80B2-3E111F6806C6}" destId="{AEFEFF65-2B6B-49AD-9BBE-F69ADBC409B3}" srcOrd="2" destOrd="0" presId="urn:microsoft.com/office/officeart/2005/8/layout/default"/>
+    <dgm:cxn modelId="{25710875-863B-419E-8F33-037636DD1B34}" type="presParOf" srcId="{DCB7562D-B22F-443D-80B2-3E111F6806C6}" destId="{D03D1E8F-6B05-4BB6-A15E-D34045A7785D}" srcOrd="3" destOrd="0" presId="urn:microsoft.com/office/officeart/2005/8/layout/default"/>
+    <dgm:cxn modelId="{B6E54A95-D0BE-445F-8D01-C02DCE0F9D1D}" type="presParOf" srcId="{DCB7562D-B22F-443D-80B2-3E111F6806C6}" destId="{B0076D32-3A80-4DFE-BFB6-E5115B4588E3}" srcOrd="4" destOrd="0" presId="urn:microsoft.com/office/officeart/2005/8/layout/default"/>
+    <dgm:cxn modelId="{DFF72813-6ADF-4D33-A0AB-0CCE9502734E}" type="presParOf" srcId="{DCB7562D-B22F-443D-80B2-3E111F6806C6}" destId="{881577AA-6CE0-4300-94FD-7EB927A517FF}" srcOrd="5" destOrd="0" presId="urn:microsoft.com/office/officeart/2005/8/layout/default"/>
+    <dgm:cxn modelId="{623B1ED8-9F0A-456E-9DA6-9E9FFF9E89BE}" type="presParOf" srcId="{DCB7562D-B22F-443D-80B2-3E111F6806C6}" destId="{7FBE29A4-D366-46F2-B3C5-355DE09CA2CF}" srcOrd="6" destOrd="0" presId="urn:microsoft.com/office/officeart/2005/8/layout/default"/>
+    <dgm:cxn modelId="{CD33C63F-3B40-4B4B-92C1-CDA713D93126}" type="presParOf" srcId="{DCB7562D-B22F-443D-80B2-3E111F6806C6}" destId="{AB4F864A-6E41-461B-83FC-FD59F4AE7E2D}" srcOrd="7" destOrd="0" presId="urn:microsoft.com/office/officeart/2005/8/layout/default"/>
+    <dgm:cxn modelId="{DB3CAE3D-66B6-4773-82E5-D0B824FDC6FB}" type="presParOf" srcId="{DCB7562D-B22F-443D-80B2-3E111F6806C6}" destId="{4143995B-ECD7-45B9-B0BE-9FFB5719AB3D}" srcOrd="8" destOrd="0" presId="urn:microsoft.com/office/officeart/2005/8/layout/default"/>
   </dgm:cxnLst>
   <dgm:bg/>
   <dgm:whole/>
@@ -2111,15 +2111,15 @@
       <dsp:cNvGrpSpPr/>
     </dsp:nvGrpSpPr>
     <dsp:grpSpPr/>
-    <dsp:sp modelId="{A63750CF-CF92-4612-BE76-0B0FFC57B29F}">
+    <dsp:sp modelId="{1F55CCF8-CF93-4880-A199-6B92E47F3C72}">
       <dsp:nvSpPr>
         <dsp:cNvPr id="0" name=""/>
         <dsp:cNvSpPr/>
       </dsp:nvSpPr>
       <dsp:spPr>
         <a:xfrm>
-          <a:off x="904825" y="2976"/>
-          <a:ext cx="2283023" cy="1369814"/>
+          <a:off x="1104589" y="2728"/>
+          <a:ext cx="2092771" cy="1255662"/>
         </a:xfrm>
         <a:prstGeom prst="rect">
           <a:avLst/>
@@ -2161,12 +2161,12 @@
         </a:fontRef>
       </dsp:style>
       <dsp:txBody>
-        <a:bodyPr spcFirstLastPara="0" vert="horz" wrap="square" lIns="236220" tIns="236220" rIns="236220" bIns="236220" numCol="1" spcCol="1270" anchor="ctr" anchorCtr="0">
+        <a:bodyPr spcFirstLastPara="0" vert="horz" wrap="square" lIns="217170" tIns="217170" rIns="217170" bIns="217170" numCol="1" spcCol="1270" anchor="ctr" anchorCtr="0">
           <a:noAutofit/>
         </a:bodyPr>
         <a:lstStyle/>
         <a:p>
-          <a:pPr marL="0" lvl="0" indent="0" algn="ctr" defTabSz="2755900">
+          <a:pPr marL="0" lvl="0" indent="0" algn="ctr" defTabSz="2533650">
             <a:lnSpc>
               <a:spcPct val="90000"/>
             </a:lnSpc>
@@ -2178,23 +2178,23 @@
             </a:spcAft>
             <a:buNone/>
           </a:pPr>
-          <a:endParaRPr lang="en-US" sz="6200" kern="1200"/>
+          <a:endParaRPr lang="en-US" sz="5700" kern="1200"/>
         </a:p>
       </dsp:txBody>
       <dsp:txXfrm>
-        <a:off x="904825" y="2976"/>
-        <a:ext cx="2283023" cy="1369814"/>
+        <a:off x="1104589" y="2728"/>
+        <a:ext cx="2092771" cy="1255662"/>
       </dsp:txXfrm>
     </dsp:sp>
-    <dsp:sp modelId="{1B23FE2D-A12E-42DF-8E10-EB2DBB93FF5F}">
+    <dsp:sp modelId="{AEFEFF65-2B6B-49AD-9BBE-F69ADBC409B3}">
       <dsp:nvSpPr>
         <dsp:cNvPr id="0" name=""/>
         <dsp:cNvSpPr/>
       </dsp:nvSpPr>
       <dsp:spPr>
         <a:xfrm>
-          <a:off x="3416151" y="2976"/>
-          <a:ext cx="2283023" cy="1369814"/>
+          <a:off x="3406638" y="2728"/>
+          <a:ext cx="2092771" cy="1255662"/>
         </a:xfrm>
         <a:prstGeom prst="rect">
           <a:avLst/>
@@ -2236,12 +2236,12 @@
         </a:fontRef>
       </dsp:style>
       <dsp:txBody>
-        <a:bodyPr spcFirstLastPara="0" vert="horz" wrap="square" lIns="236220" tIns="236220" rIns="236220" bIns="236220" numCol="1" spcCol="1270" anchor="ctr" anchorCtr="0">
+        <a:bodyPr spcFirstLastPara="0" vert="horz" wrap="square" lIns="217170" tIns="217170" rIns="217170" bIns="217170" numCol="1" spcCol="1270" anchor="ctr" anchorCtr="0">
           <a:noAutofit/>
         </a:bodyPr>
         <a:lstStyle/>
         <a:p>
-          <a:pPr marL="0" lvl="0" indent="0" algn="ctr" defTabSz="2755900">
+          <a:pPr marL="0" lvl="0" indent="0" algn="ctr" defTabSz="2533650">
             <a:lnSpc>
               <a:spcPct val="90000"/>
             </a:lnSpc>
@@ -2253,23 +2253,23 @@
             </a:spcAft>
             <a:buNone/>
           </a:pPr>
-          <a:endParaRPr lang="en-US" sz="6200" kern="1200"/>
+          <a:endParaRPr lang="en-US" sz="5700" kern="1200"/>
         </a:p>
       </dsp:txBody>
       <dsp:txXfrm>
-        <a:off x="3416151" y="2976"/>
-        <a:ext cx="2283023" cy="1369814"/>
+        <a:off x="3406638" y="2728"/>
+        <a:ext cx="2092771" cy="1255662"/>
       </dsp:txXfrm>
     </dsp:sp>
-    <dsp:sp modelId="{29E9B170-CB20-4F37-8D80-CB70BB392088}">
+    <dsp:sp modelId="{B0076D32-3A80-4DFE-BFB6-E5115B4588E3}">
       <dsp:nvSpPr>
         <dsp:cNvPr id="0" name=""/>
         <dsp:cNvSpPr/>
       </dsp:nvSpPr>
       <dsp:spPr>
         <a:xfrm>
-          <a:off x="904825" y="1601092"/>
-          <a:ext cx="2283023" cy="1369814"/>
+          <a:off x="1104589" y="1467668"/>
+          <a:ext cx="2092771" cy="1255662"/>
         </a:xfrm>
         <a:prstGeom prst="rect">
           <a:avLst/>
@@ -2311,12 +2311,12 @@
         </a:fontRef>
       </dsp:style>
       <dsp:txBody>
-        <a:bodyPr spcFirstLastPara="0" vert="horz" wrap="square" lIns="236220" tIns="236220" rIns="236220" bIns="236220" numCol="1" spcCol="1270" anchor="ctr" anchorCtr="0">
+        <a:bodyPr spcFirstLastPara="0" vert="horz" wrap="square" lIns="217170" tIns="217170" rIns="217170" bIns="217170" numCol="1" spcCol="1270" anchor="ctr" anchorCtr="0">
           <a:noAutofit/>
         </a:bodyPr>
         <a:lstStyle/>
         <a:p>
-          <a:pPr marL="0" lvl="0" indent="0" algn="ctr" defTabSz="2755900">
+          <a:pPr marL="0" lvl="0" indent="0" algn="ctr" defTabSz="2533650">
             <a:lnSpc>
               <a:spcPct val="90000"/>
             </a:lnSpc>
@@ -2328,23 +2328,23 @@
             </a:spcAft>
             <a:buNone/>
           </a:pPr>
-          <a:endParaRPr lang="en-US" sz="6200" kern="1200"/>
+          <a:endParaRPr lang="en-US" sz="5700" kern="1200"/>
         </a:p>
       </dsp:txBody>
       <dsp:txXfrm>
-        <a:off x="904825" y="1601092"/>
-        <a:ext cx="2283023" cy="1369814"/>
+        <a:off x="1104589" y="1467668"/>
+        <a:ext cx="2092771" cy="1255662"/>
       </dsp:txXfrm>
     </dsp:sp>
-    <dsp:sp modelId="{83BCF00E-6EA6-41C0-83D9-295109D26297}">
+    <dsp:sp modelId="{7FBE29A4-D366-46F2-B3C5-355DE09CA2CF}">
       <dsp:nvSpPr>
         <dsp:cNvPr id="0" name=""/>
         <dsp:cNvSpPr/>
       </dsp:nvSpPr>
       <dsp:spPr>
         <a:xfrm>
-          <a:off x="3416151" y="1601092"/>
-          <a:ext cx="2283023" cy="1369814"/>
+          <a:off x="3406638" y="1467668"/>
+          <a:ext cx="2092771" cy="1255662"/>
         </a:xfrm>
         <a:prstGeom prst="rect">
           <a:avLst/>
@@ -2386,12 +2386,12 @@
         </a:fontRef>
       </dsp:style>
       <dsp:txBody>
-        <a:bodyPr spcFirstLastPara="0" vert="horz" wrap="square" lIns="236220" tIns="236220" rIns="236220" bIns="236220" numCol="1" spcCol="1270" anchor="ctr" anchorCtr="0">
+        <a:bodyPr spcFirstLastPara="0" vert="horz" wrap="square" lIns="217170" tIns="217170" rIns="217170" bIns="217170" numCol="1" spcCol="1270" anchor="ctr" anchorCtr="0">
           <a:noAutofit/>
         </a:bodyPr>
         <a:lstStyle/>
         <a:p>
-          <a:pPr marL="0" lvl="0" indent="0" algn="ctr" defTabSz="2755900">
+          <a:pPr marL="0" lvl="0" indent="0" algn="ctr" defTabSz="2533650">
             <a:lnSpc>
               <a:spcPct val="90000"/>
             </a:lnSpc>
@@ -2403,23 +2403,23 @@
             </a:spcAft>
             <a:buNone/>
           </a:pPr>
-          <a:endParaRPr lang="en-US" sz="6200" kern="1200"/>
+          <a:endParaRPr lang="en-US" sz="5700" kern="1200"/>
         </a:p>
       </dsp:txBody>
       <dsp:txXfrm>
-        <a:off x="3416151" y="1601092"/>
-        <a:ext cx="2283023" cy="1369814"/>
+        <a:off x="3406638" y="1467668"/>
+        <a:ext cx="2092771" cy="1255662"/>
       </dsp:txXfrm>
     </dsp:sp>
-    <dsp:sp modelId="{F29CF895-B683-4FFD-B5E7-E9B1CFD72E2F}">
+    <dsp:sp modelId="{4143995B-ECD7-45B9-B0BE-9FFB5719AB3D}">
       <dsp:nvSpPr>
         <dsp:cNvPr id="0" name=""/>
         <dsp:cNvSpPr/>
       </dsp:nvSpPr>
       <dsp:spPr>
         <a:xfrm>
-          <a:off x="2160488" y="3199209"/>
-          <a:ext cx="2283023" cy="1369814"/>
+          <a:off x="2255614" y="2932608"/>
+          <a:ext cx="2092771" cy="1255662"/>
         </a:xfrm>
         <a:prstGeom prst="rect">
           <a:avLst/>
@@ -2461,12 +2461,12 @@
         </a:fontRef>
       </dsp:style>
       <dsp:txBody>
-        <a:bodyPr spcFirstLastPara="0" vert="horz" wrap="square" lIns="236220" tIns="236220" rIns="236220" bIns="236220" numCol="1" spcCol="1270" anchor="ctr" anchorCtr="0">
+        <a:bodyPr spcFirstLastPara="0" vert="horz" wrap="square" lIns="217170" tIns="217170" rIns="217170" bIns="217170" numCol="1" spcCol="1270" anchor="ctr" anchorCtr="0">
           <a:noAutofit/>
         </a:bodyPr>
         <a:lstStyle/>
         <a:p>
-          <a:pPr marL="0" lvl="0" indent="0" algn="ctr" defTabSz="2755900">
+          <a:pPr marL="0" lvl="0" indent="0" algn="ctr" defTabSz="2533650">
             <a:lnSpc>
               <a:spcPct val="90000"/>
             </a:lnSpc>
@@ -2478,12 +2478,12 @@
             </a:spcAft>
             <a:buNone/>
           </a:pPr>
-          <a:endParaRPr lang="en-US" sz="6200" kern="1200"/>
+          <a:endParaRPr lang="en-US" sz="5700" kern="1200"/>
         </a:p>
       </dsp:txBody>
       <dsp:txXfrm>
-        <a:off x="2160488" y="3199209"/>
-        <a:ext cx="2283023" cy="1369814"/>
+        <a:off x="2255614" y="2932608"/>
+        <a:ext cx="2092771" cy="1255662"/>
       </dsp:txXfrm>
     </dsp:sp>
   </dsp:spTree>
@@ -3693,7 +3693,7 @@
           <p:cNvPr id="2" name="Title 1">
             <a:extLst>
               <a:ext uri="{FF2B5EF4-FFF2-40B4-BE49-F238E27FC236}">
-                <a16:creationId xmlns:a16="http://schemas.microsoft.com/office/drawing/2014/main" id="{5724B9AA-C7F5-F7C6-C45D-E23D204C6F10}"/>
+                <a16:creationId xmlns:a16="http://schemas.microsoft.com/office/drawing/2014/main" id="{8CB34957-3ACD-E8F8-43B7-837CE37CB5F8}"/>
               </a:ext>
             </a:extLst>
           </p:cNvPr>
@@ -3730,7 +3730,7 @@
           <p:cNvPr id="3" name="Subtitle 2">
             <a:extLst>
               <a:ext uri="{FF2B5EF4-FFF2-40B4-BE49-F238E27FC236}">
-                <a16:creationId xmlns:a16="http://schemas.microsoft.com/office/drawing/2014/main" id="{225907B7-DFDF-88C9-15BA-87AD06DBBCED}"/>
+                <a16:creationId xmlns:a16="http://schemas.microsoft.com/office/drawing/2014/main" id="{331B891A-0188-CB30-35F1-35EA2C53A115}"/>
               </a:ext>
             </a:extLst>
           </p:cNvPr>
@@ -3800,7 +3800,7 @@
           <p:cNvPr id="4" name="Date Placeholder 3">
             <a:extLst>
               <a:ext uri="{FF2B5EF4-FFF2-40B4-BE49-F238E27FC236}">
-                <a16:creationId xmlns:a16="http://schemas.microsoft.com/office/drawing/2014/main" id="{D8C44403-85F6-7ACC-632C-ABF9A61BC77D}"/>
+                <a16:creationId xmlns:a16="http://schemas.microsoft.com/office/drawing/2014/main" id="{38954536-32C4-6698-A875-BAED27B22771}"/>
               </a:ext>
             </a:extLst>
           </p:cNvPr>
@@ -3816,7 +3816,7 @@
           <a:bodyPr/>
           <a:lstStyle/>
           <a:p>
-            <a:fld id="{DD10DBA1-B260-4C9A-B5A0-D8DFDAF8F44C}" type="datetimeFigureOut">
+            <a:fld id="{4CB72EDE-F85A-4F2B-B9E0-665BB0BB45EB}" type="datetimeFigureOut">
               <a:rPr lang="en-US" smtClean="0"/>
               <a:t>2026-07-23</a:t>
             </a:fld>
@@ -3829,7 +3829,7 @@
           <p:cNvPr id="5" name="Footer Placeholder 4">
             <a:extLst>
               <a:ext uri="{FF2B5EF4-FFF2-40B4-BE49-F238E27FC236}">
-                <a16:creationId xmlns:a16="http://schemas.microsoft.com/office/drawing/2014/main" id="{DABEB19A-F719-36AC-6263-F74956EEF70D}"/>
+                <a16:creationId xmlns:a16="http://schemas.microsoft.com/office/drawing/2014/main" id="{D5F3A8AA-F730-3878-7F37-7B963CFD5417}"/>
               </a:ext>
             </a:extLst>
           </p:cNvPr>
@@ -3854,7 +3854,7 @@
           <p:cNvPr id="6" name="Slide Number Placeholder 5">
             <a:extLst>
               <a:ext uri="{FF2B5EF4-FFF2-40B4-BE49-F238E27FC236}">
-                <a16:creationId xmlns:a16="http://schemas.microsoft.com/office/drawing/2014/main" id="{9E2E291F-058F-3140-BAB5-56A04DF64D6E}"/>
+                <a16:creationId xmlns:a16="http://schemas.microsoft.com/office/drawing/2014/main" id="{5E89202F-24BB-FA3F-DB03-93AD71B81557}"/>
               </a:ext>
             </a:extLst>
           </p:cNvPr>
@@ -3870,7 +3870,7 @@
           <a:bodyPr/>
           <a:lstStyle/>
           <a:p>
-            <a:fld id="{983EC104-1EB6-4709-99AD-1B097D015398}" type="slidenum">
+            <a:fld id="{C8563E8A-7FC4-4D37-AA23-5DF556F6A4CD}" type="slidenum">
               <a:rPr lang="en-US" smtClean="0"/>
               <a:t>‹#›</a:t>
             </a:fld>
@@ -3881,7 +3881,7 @@
     </p:spTree>
     <p:extLst>
       <p:ext uri="{BB962C8B-B14F-4D97-AF65-F5344CB8AC3E}">
-        <p14:creationId xmlns:p14="http://schemas.microsoft.com/office/powerpoint/2010/main" val="3287136197"/>
+        <p14:creationId xmlns:p14="http://schemas.microsoft.com/office/powerpoint/2010/main" val="693648845"/>
       </p:ext>
     </p:extLst>
   </p:cSld>
@@ -3913,7 +3913,7 @@
           <p:cNvPr id="2" name="Title 1">
             <a:extLst>
               <a:ext uri="{FF2B5EF4-FFF2-40B4-BE49-F238E27FC236}">
-                <a16:creationId xmlns:a16="http://schemas.microsoft.com/office/drawing/2014/main" id="{3467144A-2703-C2B8-D1C2-F79449995CD2}"/>
+                <a16:creationId xmlns:a16="http://schemas.microsoft.com/office/drawing/2014/main" id="{506453F4-B1C9-2A74-0263-F4BD7AC8BAAA}"/>
               </a:ext>
             </a:extLst>
           </p:cNvPr>
@@ -3941,7 +3941,7 @@
           <p:cNvPr id="3" name="Vertical Text Placeholder 2">
             <a:extLst>
               <a:ext uri="{FF2B5EF4-FFF2-40B4-BE49-F238E27FC236}">
-                <a16:creationId xmlns:a16="http://schemas.microsoft.com/office/drawing/2014/main" id="{10965BA4-4995-D434-4D9A-A16BD14AE061}"/>
+                <a16:creationId xmlns:a16="http://schemas.microsoft.com/office/drawing/2014/main" id="{E6B063AA-44FC-207A-7B0C-BA9D7A1E6EC2}"/>
               </a:ext>
             </a:extLst>
           </p:cNvPr>
@@ -3998,7 +3998,7 @@
           <p:cNvPr id="4" name="Date Placeholder 3">
             <a:extLst>
               <a:ext uri="{FF2B5EF4-FFF2-40B4-BE49-F238E27FC236}">
-                <a16:creationId xmlns:a16="http://schemas.microsoft.com/office/drawing/2014/main" id="{12B65B08-50FE-63FA-15CB-2083AFEC2085}"/>
+                <a16:creationId xmlns:a16="http://schemas.microsoft.com/office/drawing/2014/main" id="{C37E8B1C-17DE-7983-ADBC-CACE04081679}"/>
               </a:ext>
             </a:extLst>
           </p:cNvPr>
@@ -4014,7 +4014,7 @@
           <a:bodyPr/>
           <a:lstStyle/>
           <a:p>
-            <a:fld id="{DD10DBA1-B260-4C9A-B5A0-D8DFDAF8F44C}" type="datetimeFigureOut">
+            <a:fld id="{4CB72EDE-F85A-4F2B-B9E0-665BB0BB45EB}" type="datetimeFigureOut">
               <a:rPr lang="en-US" smtClean="0"/>
               <a:t>2026-07-23</a:t>
             </a:fld>
@@ -4027,7 +4027,7 @@
           <p:cNvPr id="5" name="Footer Placeholder 4">
             <a:extLst>
               <a:ext uri="{FF2B5EF4-FFF2-40B4-BE49-F238E27FC236}">
-                <a16:creationId xmlns:a16="http://schemas.microsoft.com/office/drawing/2014/main" id="{9FF09CC3-DFC0-869E-983D-D4E725FE4404}"/>
+                <a16:creationId xmlns:a16="http://schemas.microsoft.com/office/drawing/2014/main" id="{A93A0DF6-6187-3C53-F401-54F35EB002FB}"/>
               </a:ext>
             </a:extLst>
           </p:cNvPr>
@@ -4052,7 +4052,7 @@
           <p:cNvPr id="6" name="Slide Number Placeholder 5">
             <a:extLst>
               <a:ext uri="{FF2B5EF4-FFF2-40B4-BE49-F238E27FC236}">
-                <a16:creationId xmlns:a16="http://schemas.microsoft.com/office/drawing/2014/main" id="{3167329C-3717-3C18-796A-D12162E44A98}"/>
+                <a16:creationId xmlns:a16="http://schemas.microsoft.com/office/drawing/2014/main" id="{2F22CDBA-2EB5-EF07-96D4-7CB4D1F1B620}"/>
               </a:ext>
             </a:extLst>
           </p:cNvPr>
@@ -4068,7 +4068,7 @@
           <a:bodyPr/>
           <a:lstStyle/>
           <a:p>
-            <a:fld id="{983EC104-1EB6-4709-99AD-1B097D015398}" type="slidenum">
+            <a:fld id="{C8563E8A-7FC4-4D37-AA23-5DF556F6A4CD}" type="slidenum">
               <a:rPr lang="en-US" smtClean="0"/>
               <a:t>‹#›</a:t>
             </a:fld>
@@ -4079,7 +4079,7 @@
     </p:spTree>
     <p:extLst>
       <p:ext uri="{BB962C8B-B14F-4D97-AF65-F5344CB8AC3E}">
-        <p14:creationId xmlns:p14="http://schemas.microsoft.com/office/powerpoint/2010/main" val="2115020179"/>
+        <p14:creationId xmlns:p14="http://schemas.microsoft.com/office/powerpoint/2010/main" val="878476181"/>
       </p:ext>
     </p:extLst>
   </p:cSld>
@@ -4111,7 +4111,7 @@
           <p:cNvPr id="2" name="Vertical Title 1">
             <a:extLst>
               <a:ext uri="{FF2B5EF4-FFF2-40B4-BE49-F238E27FC236}">
-                <a16:creationId xmlns:a16="http://schemas.microsoft.com/office/drawing/2014/main" id="{D91F0B07-4105-ACB9-8B6D-0429D55EE7C4}"/>
+                <a16:creationId xmlns:a16="http://schemas.microsoft.com/office/drawing/2014/main" id="{6A8D30AC-F03F-1992-D904-A5FCD06AA4BD}"/>
               </a:ext>
             </a:extLst>
           </p:cNvPr>
@@ -4144,7 +4144,7 @@
           <p:cNvPr id="3" name="Vertical Text Placeholder 2">
             <a:extLst>
               <a:ext uri="{FF2B5EF4-FFF2-40B4-BE49-F238E27FC236}">
-                <a16:creationId xmlns:a16="http://schemas.microsoft.com/office/drawing/2014/main" id="{53F1F833-B6C3-8F40-880D-72907E04A9FD}"/>
+                <a16:creationId xmlns:a16="http://schemas.microsoft.com/office/drawing/2014/main" id="{C2D7F9E2-D694-CF74-D787-23A14BC26102}"/>
               </a:ext>
             </a:extLst>
           </p:cNvPr>
@@ -4206,7 +4206,7 @@
           <p:cNvPr id="4" name="Date Placeholder 3">
             <a:extLst>
               <a:ext uri="{FF2B5EF4-FFF2-40B4-BE49-F238E27FC236}">
-                <a16:creationId xmlns:a16="http://schemas.microsoft.com/office/drawing/2014/main" id="{10D53020-43B6-E5F4-667B-B6572395D01F}"/>
+                <a16:creationId xmlns:a16="http://schemas.microsoft.com/office/drawing/2014/main" id="{A17C6878-6B16-18D5-6342-237436856C4A}"/>
               </a:ext>
             </a:extLst>
           </p:cNvPr>
@@ -4222,7 +4222,7 @@
           <a:bodyPr/>
           <a:lstStyle/>
           <a:p>
-            <a:fld id="{DD10DBA1-B260-4C9A-B5A0-D8DFDAF8F44C}" type="datetimeFigureOut">
+            <a:fld id="{4CB72EDE-F85A-4F2B-B9E0-665BB0BB45EB}" type="datetimeFigureOut">
               <a:rPr lang="en-US" smtClean="0"/>
               <a:t>2026-07-23</a:t>
             </a:fld>
@@ -4235,7 +4235,7 @@
           <p:cNvPr id="5" name="Footer Placeholder 4">
             <a:extLst>
               <a:ext uri="{FF2B5EF4-FFF2-40B4-BE49-F238E27FC236}">
-                <a16:creationId xmlns:a16="http://schemas.microsoft.com/office/drawing/2014/main" id="{3FF9DCD3-894E-F53F-7F0A-95C65A4384D7}"/>
+                <a16:creationId xmlns:a16="http://schemas.microsoft.com/office/drawing/2014/main" id="{38F8E058-D32E-EA72-6584-C37222ECC556}"/>
               </a:ext>
             </a:extLst>
           </p:cNvPr>
@@ -4260,7 +4260,7 @@
           <p:cNvPr id="6" name="Slide Number Placeholder 5">
             <a:extLst>
               <a:ext uri="{FF2B5EF4-FFF2-40B4-BE49-F238E27FC236}">
-                <a16:creationId xmlns:a16="http://schemas.microsoft.com/office/drawing/2014/main" id="{E1FA7942-F75A-0F26-90CF-F5BD5E3C7E8C}"/>
+                <a16:creationId xmlns:a16="http://schemas.microsoft.com/office/drawing/2014/main" id="{D12C22CF-9088-FF09-54C1-E1D212278324}"/>
               </a:ext>
             </a:extLst>
           </p:cNvPr>
@@ -4276,7 +4276,7 @@
           <a:bodyPr/>
           <a:lstStyle/>
           <a:p>
-            <a:fld id="{983EC104-1EB6-4709-99AD-1B097D015398}" type="slidenum">
+            <a:fld id="{C8563E8A-7FC4-4D37-AA23-5DF556F6A4CD}" type="slidenum">
               <a:rPr lang="en-US" smtClean="0"/>
               <a:t>‹#›</a:t>
             </a:fld>
@@ -4287,7 +4287,7 @@
     </p:spTree>
     <p:extLst>
       <p:ext uri="{BB962C8B-B14F-4D97-AF65-F5344CB8AC3E}">
-        <p14:creationId xmlns:p14="http://schemas.microsoft.com/office/powerpoint/2010/main" val="3993327553"/>
+        <p14:creationId xmlns:p14="http://schemas.microsoft.com/office/powerpoint/2010/main" val="3941077757"/>
       </p:ext>
     </p:extLst>
   </p:cSld>
@@ -4319,7 +4319,7 @@
           <p:cNvPr id="2" name="Title 1">
             <a:extLst>
               <a:ext uri="{FF2B5EF4-FFF2-40B4-BE49-F238E27FC236}">
-                <a16:creationId xmlns:a16="http://schemas.microsoft.com/office/drawing/2014/main" id="{44B3D855-C632-D7F6-2B6F-6EA73FE674A4}"/>
+                <a16:creationId xmlns:a16="http://schemas.microsoft.com/office/drawing/2014/main" id="{C62E96E4-7CD9-95E6-04D1-935B95CB80F3}"/>
               </a:ext>
             </a:extLst>
           </p:cNvPr>
@@ -4347,7 +4347,7 @@
           <p:cNvPr id="3" name="Content Placeholder 2">
             <a:extLst>
               <a:ext uri="{FF2B5EF4-FFF2-40B4-BE49-F238E27FC236}">
-                <a16:creationId xmlns:a16="http://schemas.microsoft.com/office/drawing/2014/main" id="{1731DF36-A5A2-87B6-D6CA-0B26D0AB28CF}"/>
+                <a16:creationId xmlns:a16="http://schemas.microsoft.com/office/drawing/2014/main" id="{45E620B7-FE32-17EA-9C99-F30573177235}"/>
               </a:ext>
             </a:extLst>
           </p:cNvPr>
@@ -4404,7 +4404,7 @@
           <p:cNvPr id="4" name="Date Placeholder 3">
             <a:extLst>
               <a:ext uri="{FF2B5EF4-FFF2-40B4-BE49-F238E27FC236}">
-                <a16:creationId xmlns:a16="http://schemas.microsoft.com/office/drawing/2014/main" id="{48C2C53C-0EF1-CCB4-7AA1-715AF71BE65C}"/>
+                <a16:creationId xmlns:a16="http://schemas.microsoft.com/office/drawing/2014/main" id="{EEA120CA-D05B-3B35-E905-8988092804B0}"/>
               </a:ext>
             </a:extLst>
           </p:cNvPr>
@@ -4420,7 +4420,7 @@
           <a:bodyPr/>
           <a:lstStyle/>
           <a:p>
-            <a:fld id="{DD10DBA1-B260-4C9A-B5A0-D8DFDAF8F44C}" type="datetimeFigureOut">
+            <a:fld id="{4CB72EDE-F85A-4F2B-B9E0-665BB0BB45EB}" type="datetimeFigureOut">
               <a:rPr lang="en-US" smtClean="0"/>
               <a:t>2026-07-23</a:t>
             </a:fld>
@@ -4433,7 +4433,7 @@
           <p:cNvPr id="5" name="Footer Placeholder 4">
             <a:extLst>
               <a:ext uri="{FF2B5EF4-FFF2-40B4-BE49-F238E27FC236}">
-                <a16:creationId xmlns:a16="http://schemas.microsoft.com/office/drawing/2014/main" id="{2CE3D408-6CCA-2784-D87B-C116B3431ACC}"/>
+                <a16:creationId xmlns:a16="http://schemas.microsoft.com/office/drawing/2014/main" id="{1FD342E3-9EA9-D5F6-2588-27743270B39E}"/>
               </a:ext>
             </a:extLst>
           </p:cNvPr>
@@ -4458,7 +4458,7 @@
           <p:cNvPr id="6" name="Slide Number Placeholder 5">
             <a:extLst>
               <a:ext uri="{FF2B5EF4-FFF2-40B4-BE49-F238E27FC236}">
-                <a16:creationId xmlns:a16="http://schemas.microsoft.com/office/drawing/2014/main" id="{E8EC2B00-4ED1-E3A5-324F-BB6964FF624E}"/>
+                <a16:creationId xmlns:a16="http://schemas.microsoft.com/office/drawing/2014/main" id="{0A577FA0-B1F3-3168-BA53-DDB4CE5329A8}"/>
               </a:ext>
             </a:extLst>
           </p:cNvPr>
@@ -4474,7 +4474,7 @@
           <a:bodyPr/>
           <a:lstStyle/>
           <a:p>
-            <a:fld id="{983EC104-1EB6-4709-99AD-1B097D015398}" type="slidenum">
+            <a:fld id="{C8563E8A-7FC4-4D37-AA23-5DF556F6A4CD}" type="slidenum">
               <a:rPr lang="en-US" smtClean="0"/>
               <a:t>‹#›</a:t>
             </a:fld>
@@ -4485,7 +4485,7 @@
     </p:spTree>
     <p:extLst>
       <p:ext uri="{BB962C8B-B14F-4D97-AF65-F5344CB8AC3E}">
-        <p14:creationId xmlns:p14="http://schemas.microsoft.com/office/powerpoint/2010/main" val="524608258"/>
+        <p14:creationId xmlns:p14="http://schemas.microsoft.com/office/powerpoint/2010/main" val="609204893"/>
       </p:ext>
     </p:extLst>
   </p:cSld>
@@ -4517,7 +4517,7 @@
           <p:cNvPr id="2" name="Title 1">
             <a:extLst>
               <a:ext uri="{FF2B5EF4-FFF2-40B4-BE49-F238E27FC236}">
-                <a16:creationId xmlns:a16="http://schemas.microsoft.com/office/drawing/2014/main" id="{44E427AE-2686-9621-8A87-7345E0117EB7}"/>
+                <a16:creationId xmlns:a16="http://schemas.microsoft.com/office/drawing/2014/main" id="{56DF80DE-3D02-E860-4A84-30F686772019}"/>
               </a:ext>
             </a:extLst>
           </p:cNvPr>
@@ -4554,7 +4554,7 @@
           <p:cNvPr id="3" name="Text Placeholder 2">
             <a:extLst>
               <a:ext uri="{FF2B5EF4-FFF2-40B4-BE49-F238E27FC236}">
-                <a16:creationId xmlns:a16="http://schemas.microsoft.com/office/drawing/2014/main" id="{EE92AFA6-3974-64B7-6313-96AF0E9FC9DF}"/>
+                <a16:creationId xmlns:a16="http://schemas.microsoft.com/office/drawing/2014/main" id="{D8547E22-2B54-DB49-DCAD-8899B2C2A49F}"/>
               </a:ext>
             </a:extLst>
           </p:cNvPr>
@@ -4679,7 +4679,7 @@
           <p:cNvPr id="4" name="Date Placeholder 3">
             <a:extLst>
               <a:ext uri="{FF2B5EF4-FFF2-40B4-BE49-F238E27FC236}">
-                <a16:creationId xmlns:a16="http://schemas.microsoft.com/office/drawing/2014/main" id="{C4EECE92-CE4F-76E3-429E-205F9D2CB889}"/>
+                <a16:creationId xmlns:a16="http://schemas.microsoft.com/office/drawing/2014/main" id="{E4F69987-1758-AAC3-AAFC-3ADCC93184AB}"/>
               </a:ext>
             </a:extLst>
           </p:cNvPr>
@@ -4695,7 +4695,7 @@
           <a:bodyPr/>
           <a:lstStyle/>
           <a:p>
-            <a:fld id="{DD10DBA1-B260-4C9A-B5A0-D8DFDAF8F44C}" type="datetimeFigureOut">
+            <a:fld id="{4CB72EDE-F85A-4F2B-B9E0-665BB0BB45EB}" type="datetimeFigureOut">
               <a:rPr lang="en-US" smtClean="0"/>
               <a:t>2026-07-23</a:t>
             </a:fld>
@@ -4708,7 +4708,7 @@
           <p:cNvPr id="5" name="Footer Placeholder 4">
             <a:extLst>
               <a:ext uri="{FF2B5EF4-FFF2-40B4-BE49-F238E27FC236}">
-                <a16:creationId xmlns:a16="http://schemas.microsoft.com/office/drawing/2014/main" id="{3341E24E-6CFB-306D-D25A-7DCB2FCDAD07}"/>
+                <a16:creationId xmlns:a16="http://schemas.microsoft.com/office/drawing/2014/main" id="{ADF9D397-5910-ED28-961E-1FEE8192DF2C}"/>
               </a:ext>
             </a:extLst>
           </p:cNvPr>
@@ -4733,7 +4733,7 @@
           <p:cNvPr id="6" name="Slide Number Placeholder 5">
             <a:extLst>
               <a:ext uri="{FF2B5EF4-FFF2-40B4-BE49-F238E27FC236}">
-                <a16:creationId xmlns:a16="http://schemas.microsoft.com/office/drawing/2014/main" id="{B4741149-5D6C-5536-8B05-2215E9F6D8F3}"/>
+                <a16:creationId xmlns:a16="http://schemas.microsoft.com/office/drawing/2014/main" id="{3054A2D9-AB27-A2A1-2B43-72C08E538A20}"/>
               </a:ext>
             </a:extLst>
           </p:cNvPr>
@@ -4749,7 +4749,7 @@
           <a:bodyPr/>
           <a:lstStyle/>
           <a:p>
-            <a:fld id="{983EC104-1EB6-4709-99AD-1B097D015398}" type="slidenum">
+            <a:fld id="{C8563E8A-7FC4-4D37-AA23-5DF556F6A4CD}" type="slidenum">
               <a:rPr lang="en-US" smtClean="0"/>
               <a:t>‹#›</a:t>
             </a:fld>
@@ -4760,7 +4760,7 @@
     </p:spTree>
     <p:extLst>
       <p:ext uri="{BB962C8B-B14F-4D97-AF65-F5344CB8AC3E}">
-        <p14:creationId xmlns:p14="http://schemas.microsoft.com/office/powerpoint/2010/main" val="326871224"/>
+        <p14:creationId xmlns:p14="http://schemas.microsoft.com/office/powerpoint/2010/main" val="271314779"/>
       </p:ext>
     </p:extLst>
   </p:cSld>
@@ -4792,7 +4792,7 @@
           <p:cNvPr id="2" name="Title 1">
             <a:extLst>
               <a:ext uri="{FF2B5EF4-FFF2-40B4-BE49-F238E27FC236}">
-                <a16:creationId xmlns:a16="http://schemas.microsoft.com/office/drawing/2014/main" id="{E5DC328B-5666-F180-57F2-F57900FBFAE8}"/>
+                <a16:creationId xmlns:a16="http://schemas.microsoft.com/office/drawing/2014/main" id="{94851E1C-8D5B-431C-07DC-ECBDD259289A}"/>
               </a:ext>
             </a:extLst>
           </p:cNvPr>
@@ -4820,7 +4820,7 @@
           <p:cNvPr id="3" name="Content Placeholder 2">
             <a:extLst>
               <a:ext uri="{FF2B5EF4-FFF2-40B4-BE49-F238E27FC236}">
-                <a16:creationId xmlns:a16="http://schemas.microsoft.com/office/drawing/2014/main" id="{4BCAC2EC-A11C-A92A-A8F9-20FAEC12FECD}"/>
+                <a16:creationId xmlns:a16="http://schemas.microsoft.com/office/drawing/2014/main" id="{C81DA4B6-CCDC-E138-59EA-4E8255DFAC9F}"/>
               </a:ext>
             </a:extLst>
           </p:cNvPr>
@@ -4882,7 +4882,7 @@
           <p:cNvPr id="4" name="Content Placeholder 3">
             <a:extLst>
               <a:ext uri="{FF2B5EF4-FFF2-40B4-BE49-F238E27FC236}">
-                <a16:creationId xmlns:a16="http://schemas.microsoft.com/office/drawing/2014/main" id="{039835AF-CF82-AE65-A937-7958D79B9EDC}"/>
+                <a16:creationId xmlns:a16="http://schemas.microsoft.com/office/drawing/2014/main" id="{68A6851B-AF4A-2151-5FB9-2FBFBBFDE34A}"/>
               </a:ext>
             </a:extLst>
           </p:cNvPr>
@@ -4944,7 +4944,7 @@
           <p:cNvPr id="5" name="Date Placeholder 4">
             <a:extLst>
               <a:ext uri="{FF2B5EF4-FFF2-40B4-BE49-F238E27FC236}">
-                <a16:creationId xmlns:a16="http://schemas.microsoft.com/office/drawing/2014/main" id="{7A4426A9-BD15-4B3F-1DEB-C08616FB4485}"/>
+                <a16:creationId xmlns:a16="http://schemas.microsoft.com/office/drawing/2014/main" id="{094F0FBF-3CD5-7FA7-BDD7-7FF715E842D6}"/>
               </a:ext>
             </a:extLst>
           </p:cNvPr>
@@ -4960,7 +4960,7 @@
           <a:bodyPr/>
           <a:lstStyle/>
           <a:p>
-            <a:fld id="{DD10DBA1-B260-4C9A-B5A0-D8DFDAF8F44C}" type="datetimeFigureOut">
+            <a:fld id="{4CB72EDE-F85A-4F2B-B9E0-665BB0BB45EB}" type="datetimeFigureOut">
               <a:rPr lang="en-US" smtClean="0"/>
               <a:t>2026-07-23</a:t>
             </a:fld>
@@ -4973,7 +4973,7 @@
           <p:cNvPr id="6" name="Footer Placeholder 5">
             <a:extLst>
               <a:ext uri="{FF2B5EF4-FFF2-40B4-BE49-F238E27FC236}">
-                <a16:creationId xmlns:a16="http://schemas.microsoft.com/office/drawing/2014/main" id="{44FE9E89-31BC-6467-9FBA-D1EC3385C218}"/>
+                <a16:creationId xmlns:a16="http://schemas.microsoft.com/office/drawing/2014/main" id="{EE5B4E76-0332-C86E-4ACA-8F7CB55CB809}"/>
               </a:ext>
             </a:extLst>
           </p:cNvPr>
@@ -4998,7 +4998,7 @@
           <p:cNvPr id="7" name="Slide Number Placeholder 6">
             <a:extLst>
               <a:ext uri="{FF2B5EF4-FFF2-40B4-BE49-F238E27FC236}">
-                <a16:creationId xmlns:a16="http://schemas.microsoft.com/office/drawing/2014/main" id="{690195B1-88A4-B376-363A-F4B78F3A1861}"/>
+                <a16:creationId xmlns:a16="http://schemas.microsoft.com/office/drawing/2014/main" id="{4EC3F77A-7785-99D6-CA15-85C6B1C9ED6B}"/>
               </a:ext>
             </a:extLst>
           </p:cNvPr>
@@ -5014,7 +5014,7 @@
           <a:bodyPr/>
           <a:lstStyle/>
           <a:p>
-            <a:fld id="{983EC104-1EB6-4709-99AD-1B097D015398}" type="slidenum">
+            <a:fld id="{C8563E8A-7FC4-4D37-AA23-5DF556F6A4CD}" type="slidenum">
               <a:rPr lang="en-US" smtClean="0"/>
               <a:t>‹#›</a:t>
             </a:fld>
@@ -5025,7 +5025,7 @@
     </p:spTree>
     <p:extLst>
       <p:ext uri="{BB962C8B-B14F-4D97-AF65-F5344CB8AC3E}">
-        <p14:creationId xmlns:p14="http://schemas.microsoft.com/office/powerpoint/2010/main" val="1703883400"/>
+        <p14:creationId xmlns:p14="http://schemas.microsoft.com/office/powerpoint/2010/main" val="3868526192"/>
       </p:ext>
     </p:extLst>
   </p:cSld>
@@ -5057,7 +5057,7 @@
           <p:cNvPr id="2" name="Title 1">
             <a:extLst>
               <a:ext uri="{FF2B5EF4-FFF2-40B4-BE49-F238E27FC236}">
-                <a16:creationId xmlns:a16="http://schemas.microsoft.com/office/drawing/2014/main" id="{9ED73871-1184-9C00-189A-835AC3D207D2}"/>
+                <a16:creationId xmlns:a16="http://schemas.microsoft.com/office/drawing/2014/main" id="{03042073-5993-7E10-F6A5-C50C0857249A}"/>
               </a:ext>
             </a:extLst>
           </p:cNvPr>
@@ -5090,7 +5090,7 @@
           <p:cNvPr id="3" name="Text Placeholder 2">
             <a:extLst>
               <a:ext uri="{FF2B5EF4-FFF2-40B4-BE49-F238E27FC236}">
-                <a16:creationId xmlns:a16="http://schemas.microsoft.com/office/drawing/2014/main" id="{85103955-FF4D-7061-6C68-E1FCD6E1C8AD}"/>
+                <a16:creationId xmlns:a16="http://schemas.microsoft.com/office/drawing/2014/main" id="{E5425695-2AA6-AD80-4053-CBEB8FB623D5}"/>
               </a:ext>
             </a:extLst>
           </p:cNvPr>
@@ -5161,7 +5161,7 @@
           <p:cNvPr id="4" name="Content Placeholder 3">
             <a:extLst>
               <a:ext uri="{FF2B5EF4-FFF2-40B4-BE49-F238E27FC236}">
-                <a16:creationId xmlns:a16="http://schemas.microsoft.com/office/drawing/2014/main" id="{1A120F35-E09A-35D4-C9A1-FEAF3474D4FB}"/>
+                <a16:creationId xmlns:a16="http://schemas.microsoft.com/office/drawing/2014/main" id="{17C39DAF-2C6C-3703-BE8A-2F2E952D9243}"/>
               </a:ext>
             </a:extLst>
           </p:cNvPr>
@@ -5223,7 +5223,7 @@
           <p:cNvPr id="5" name="Text Placeholder 4">
             <a:extLst>
               <a:ext uri="{FF2B5EF4-FFF2-40B4-BE49-F238E27FC236}">
-                <a16:creationId xmlns:a16="http://schemas.microsoft.com/office/drawing/2014/main" id="{B0AD8BA2-BC0C-5840-F8BA-0B361BA55E35}"/>
+                <a16:creationId xmlns:a16="http://schemas.microsoft.com/office/drawing/2014/main" id="{C2C6B5E4-4A44-3F56-6ABE-26D0AB8BAE95}"/>
               </a:ext>
             </a:extLst>
           </p:cNvPr>
@@ -5294,7 +5294,7 @@
           <p:cNvPr id="6" name="Content Placeholder 5">
             <a:extLst>
               <a:ext uri="{FF2B5EF4-FFF2-40B4-BE49-F238E27FC236}">
-                <a16:creationId xmlns:a16="http://schemas.microsoft.com/office/drawing/2014/main" id="{9F5F724A-FD2C-92C6-79A0-6B964F7E5778}"/>
+                <a16:creationId xmlns:a16="http://schemas.microsoft.com/office/drawing/2014/main" id="{C1CC9E53-019C-0E62-6842-D302DD38BF1F}"/>
               </a:ext>
             </a:extLst>
           </p:cNvPr>
@@ -5356,7 +5356,7 @@
           <p:cNvPr id="7" name="Date Placeholder 6">
             <a:extLst>
               <a:ext uri="{FF2B5EF4-FFF2-40B4-BE49-F238E27FC236}">
-                <a16:creationId xmlns:a16="http://schemas.microsoft.com/office/drawing/2014/main" id="{5582E2E4-7F97-A546-05C8-20AC399E4FF2}"/>
+                <a16:creationId xmlns:a16="http://schemas.microsoft.com/office/drawing/2014/main" id="{14902808-A7C1-AA1A-A9A3-1CE6D7176C4C}"/>
               </a:ext>
             </a:extLst>
           </p:cNvPr>
@@ -5372,7 +5372,7 @@
           <a:bodyPr/>
           <a:lstStyle/>
           <a:p>
-            <a:fld id="{DD10DBA1-B260-4C9A-B5A0-D8DFDAF8F44C}" type="datetimeFigureOut">
+            <a:fld id="{4CB72EDE-F85A-4F2B-B9E0-665BB0BB45EB}" type="datetimeFigureOut">
               <a:rPr lang="en-US" smtClean="0"/>
               <a:t>2026-07-23</a:t>
             </a:fld>
@@ -5385,7 +5385,7 @@
           <p:cNvPr id="8" name="Footer Placeholder 7">
             <a:extLst>
               <a:ext uri="{FF2B5EF4-FFF2-40B4-BE49-F238E27FC236}">
-                <a16:creationId xmlns:a16="http://schemas.microsoft.com/office/drawing/2014/main" id="{2E7826EC-FFBE-5F15-A9DA-9337AFA7F77D}"/>
+                <a16:creationId xmlns:a16="http://schemas.microsoft.com/office/drawing/2014/main" id="{80FFB50C-4F51-A05D-8C34-4B196DABBFFA}"/>
               </a:ext>
             </a:extLst>
           </p:cNvPr>
@@ -5410,7 +5410,7 @@
           <p:cNvPr id="9" name="Slide Number Placeholder 8">
             <a:extLst>
               <a:ext uri="{FF2B5EF4-FFF2-40B4-BE49-F238E27FC236}">
-                <a16:creationId xmlns:a16="http://schemas.microsoft.com/office/drawing/2014/main" id="{18297123-09F9-083C-B34E-9AC2958634F8}"/>
+                <a16:creationId xmlns:a16="http://schemas.microsoft.com/office/drawing/2014/main" id="{B6FD1144-F68E-1329-225E-6D5AAAB8B2E5}"/>
               </a:ext>
             </a:extLst>
           </p:cNvPr>
@@ -5426,7 +5426,7 @@
           <a:bodyPr/>
           <a:lstStyle/>
           <a:p>
-            <a:fld id="{983EC104-1EB6-4709-99AD-1B097D015398}" type="slidenum">
+            <a:fld id="{C8563E8A-7FC4-4D37-AA23-5DF556F6A4CD}" type="slidenum">
               <a:rPr lang="en-US" smtClean="0"/>
               <a:t>‹#›</a:t>
             </a:fld>
@@ -5437,7 +5437,7 @@
     </p:spTree>
     <p:extLst>
       <p:ext uri="{BB962C8B-B14F-4D97-AF65-F5344CB8AC3E}">
-        <p14:creationId xmlns:p14="http://schemas.microsoft.com/office/powerpoint/2010/main" val="3908752171"/>
+        <p14:creationId xmlns:p14="http://schemas.microsoft.com/office/powerpoint/2010/main" val="3307298409"/>
       </p:ext>
     </p:extLst>
   </p:cSld>
@@ -5469,7 +5469,7 @@
           <p:cNvPr id="2" name="Title 1">
             <a:extLst>
               <a:ext uri="{FF2B5EF4-FFF2-40B4-BE49-F238E27FC236}">
-                <a16:creationId xmlns:a16="http://schemas.microsoft.com/office/drawing/2014/main" id="{AAD5EEB6-8AE4-1887-3E42-BBCB0451A8BB}"/>
+                <a16:creationId xmlns:a16="http://schemas.microsoft.com/office/drawing/2014/main" id="{EB930AA4-995F-1DA6-6670-5AD7F2DA3B6C}"/>
               </a:ext>
             </a:extLst>
           </p:cNvPr>
@@ -5497,7 +5497,7 @@
           <p:cNvPr id="3" name="Date Placeholder 2">
             <a:extLst>
               <a:ext uri="{FF2B5EF4-FFF2-40B4-BE49-F238E27FC236}">
-                <a16:creationId xmlns:a16="http://schemas.microsoft.com/office/drawing/2014/main" id="{2A737F64-5722-AA18-A40B-F1C9E75E3C36}"/>
+                <a16:creationId xmlns:a16="http://schemas.microsoft.com/office/drawing/2014/main" id="{E9F5F79B-BC92-916C-6F44-0BB5D7138650}"/>
               </a:ext>
             </a:extLst>
           </p:cNvPr>
@@ -5513,7 +5513,7 @@
           <a:bodyPr/>
           <a:lstStyle/>
           <a:p>
-            <a:fld id="{DD10DBA1-B260-4C9A-B5A0-D8DFDAF8F44C}" type="datetimeFigureOut">
+            <a:fld id="{4CB72EDE-F85A-4F2B-B9E0-665BB0BB45EB}" type="datetimeFigureOut">
               <a:rPr lang="en-US" smtClean="0"/>
               <a:t>2026-07-23</a:t>
             </a:fld>
@@ -5526,7 +5526,7 @@
           <p:cNvPr id="4" name="Footer Placeholder 3">
             <a:extLst>
               <a:ext uri="{FF2B5EF4-FFF2-40B4-BE49-F238E27FC236}">
-                <a16:creationId xmlns:a16="http://schemas.microsoft.com/office/drawing/2014/main" id="{4D6B6F55-04A7-6F15-93C8-396AE451275D}"/>
+                <a16:creationId xmlns:a16="http://schemas.microsoft.com/office/drawing/2014/main" id="{AAEDCCD7-221A-A3E8-FCC3-133886C04DC3}"/>
               </a:ext>
             </a:extLst>
           </p:cNvPr>
@@ -5551,7 +5551,7 @@
           <p:cNvPr id="5" name="Slide Number Placeholder 4">
             <a:extLst>
               <a:ext uri="{FF2B5EF4-FFF2-40B4-BE49-F238E27FC236}">
-                <a16:creationId xmlns:a16="http://schemas.microsoft.com/office/drawing/2014/main" id="{61277DBA-79C0-BB4A-7D1B-1ADE1DDA9116}"/>
+                <a16:creationId xmlns:a16="http://schemas.microsoft.com/office/drawing/2014/main" id="{A4F61DC5-46D3-17AB-18EF-1EB7A6AA87D3}"/>
               </a:ext>
             </a:extLst>
           </p:cNvPr>
@@ -5567,7 +5567,7 @@
           <a:bodyPr/>
           <a:lstStyle/>
           <a:p>
-            <a:fld id="{983EC104-1EB6-4709-99AD-1B097D015398}" type="slidenum">
+            <a:fld id="{C8563E8A-7FC4-4D37-AA23-5DF556F6A4CD}" type="slidenum">
               <a:rPr lang="en-US" smtClean="0"/>
               <a:t>‹#›</a:t>
             </a:fld>
@@ -5578,7 +5578,7 @@
     </p:spTree>
     <p:extLst>
       <p:ext uri="{BB962C8B-B14F-4D97-AF65-F5344CB8AC3E}">
-        <p14:creationId xmlns:p14="http://schemas.microsoft.com/office/powerpoint/2010/main" val="836078111"/>
+        <p14:creationId xmlns:p14="http://schemas.microsoft.com/office/powerpoint/2010/main" val="307743470"/>
       </p:ext>
     </p:extLst>
   </p:cSld>
@@ -5610,7 +5610,7 @@
           <p:cNvPr id="2" name="Date Placeholder 1">
             <a:extLst>
               <a:ext uri="{FF2B5EF4-FFF2-40B4-BE49-F238E27FC236}">
-                <a16:creationId xmlns:a16="http://schemas.microsoft.com/office/drawing/2014/main" id="{882746FB-C068-79B6-D43E-3A9DF8505B42}"/>
+                <a16:creationId xmlns:a16="http://schemas.microsoft.com/office/drawing/2014/main" id="{23147895-22C8-3E9C-FA38-6270B7A0DF14}"/>
               </a:ext>
             </a:extLst>
           </p:cNvPr>
@@ -5626,7 +5626,7 @@
           <a:bodyPr/>
           <a:lstStyle/>
           <a:p>
-            <a:fld id="{DD10DBA1-B260-4C9A-B5A0-D8DFDAF8F44C}" type="datetimeFigureOut">
+            <a:fld id="{4CB72EDE-F85A-4F2B-B9E0-665BB0BB45EB}" type="datetimeFigureOut">
               <a:rPr lang="en-US" smtClean="0"/>
               <a:t>2026-07-23</a:t>
             </a:fld>
@@ -5639,7 +5639,7 @@
           <p:cNvPr id="3" name="Footer Placeholder 2">
             <a:extLst>
               <a:ext uri="{FF2B5EF4-FFF2-40B4-BE49-F238E27FC236}">
-                <a16:creationId xmlns:a16="http://schemas.microsoft.com/office/drawing/2014/main" id="{B64A9BE4-F45D-AE4F-BC2D-3AF82CBC14A9}"/>
+                <a16:creationId xmlns:a16="http://schemas.microsoft.com/office/drawing/2014/main" id="{0F471F63-B590-9F4C-118A-2ADB93661BC7}"/>
               </a:ext>
             </a:extLst>
           </p:cNvPr>
@@ -5664,7 +5664,7 @@
           <p:cNvPr id="4" name="Slide Number Placeholder 3">
             <a:extLst>
               <a:ext uri="{FF2B5EF4-FFF2-40B4-BE49-F238E27FC236}">
-                <a16:creationId xmlns:a16="http://schemas.microsoft.com/office/drawing/2014/main" id="{51E0435B-1ACC-6BD7-3353-CF046898D8E5}"/>
+                <a16:creationId xmlns:a16="http://schemas.microsoft.com/office/drawing/2014/main" id="{6DA1B59F-EDF3-EB05-D6B6-F26A35C5A67B}"/>
               </a:ext>
             </a:extLst>
           </p:cNvPr>
@@ -5680,7 +5680,7 @@
           <a:bodyPr/>
           <a:lstStyle/>
           <a:p>
-            <a:fld id="{983EC104-1EB6-4709-99AD-1B097D015398}" type="slidenum">
+            <a:fld id="{C8563E8A-7FC4-4D37-AA23-5DF556F6A4CD}" type="slidenum">
               <a:rPr lang="en-US" smtClean="0"/>
               <a:t>‹#›</a:t>
             </a:fld>
@@ -5691,7 +5691,7 @@
     </p:spTree>
     <p:extLst>
       <p:ext uri="{BB962C8B-B14F-4D97-AF65-F5344CB8AC3E}">
-        <p14:creationId xmlns:p14="http://schemas.microsoft.com/office/powerpoint/2010/main" val="59583317"/>
+        <p14:creationId xmlns:p14="http://schemas.microsoft.com/office/powerpoint/2010/main" val="4164625726"/>
       </p:ext>
     </p:extLst>
   </p:cSld>
@@ -5723,7 +5723,7 @@
           <p:cNvPr id="2" name="Title 1">
             <a:extLst>
               <a:ext uri="{FF2B5EF4-FFF2-40B4-BE49-F238E27FC236}">
-                <a16:creationId xmlns:a16="http://schemas.microsoft.com/office/drawing/2014/main" id="{70FB671F-4A62-A07F-804E-623F0F1D3591}"/>
+                <a16:creationId xmlns:a16="http://schemas.microsoft.com/office/drawing/2014/main" id="{15C03474-4015-550C-032B-29432A1D092D}"/>
               </a:ext>
             </a:extLst>
           </p:cNvPr>
@@ -5760,7 +5760,7 @@
           <p:cNvPr id="3" name="Content Placeholder 2">
             <a:extLst>
               <a:ext uri="{FF2B5EF4-FFF2-40B4-BE49-F238E27FC236}">
-                <a16:creationId xmlns:a16="http://schemas.microsoft.com/office/drawing/2014/main" id="{95AB8329-47B4-BB94-DDAC-592717D9F097}"/>
+                <a16:creationId xmlns:a16="http://schemas.microsoft.com/office/drawing/2014/main" id="{0BC854CA-8824-F29F-2243-84A5726CDEC4}"/>
               </a:ext>
             </a:extLst>
           </p:cNvPr>
@@ -5850,7 +5850,7 @@
           <p:cNvPr id="4" name="Text Placeholder 3">
             <a:extLst>
               <a:ext uri="{FF2B5EF4-FFF2-40B4-BE49-F238E27FC236}">
-                <a16:creationId xmlns:a16="http://schemas.microsoft.com/office/drawing/2014/main" id="{9BE824D2-EA53-1B23-0A66-8BE52CC06711}"/>
+                <a16:creationId xmlns:a16="http://schemas.microsoft.com/office/drawing/2014/main" id="{DDFA871E-E031-A443-1666-A9F47188E6DF}"/>
               </a:ext>
             </a:extLst>
           </p:cNvPr>
@@ -5921,7 +5921,7 @@
           <p:cNvPr id="5" name="Date Placeholder 4">
             <a:extLst>
               <a:ext uri="{FF2B5EF4-FFF2-40B4-BE49-F238E27FC236}">
-                <a16:creationId xmlns:a16="http://schemas.microsoft.com/office/drawing/2014/main" id="{2853CDC4-00FD-3E5D-5C8D-BFF8141C19EE}"/>
+                <a16:creationId xmlns:a16="http://schemas.microsoft.com/office/drawing/2014/main" id="{603D6122-35E3-6CCB-EA67-F47B75E69CD9}"/>
               </a:ext>
             </a:extLst>
           </p:cNvPr>
@@ -5937,7 +5937,7 @@
           <a:bodyPr/>
           <a:lstStyle/>
           <a:p>
-            <a:fld id="{DD10DBA1-B260-4C9A-B5A0-D8DFDAF8F44C}" type="datetimeFigureOut">
+            <a:fld id="{4CB72EDE-F85A-4F2B-B9E0-665BB0BB45EB}" type="datetimeFigureOut">
               <a:rPr lang="en-US" smtClean="0"/>
               <a:t>2026-07-23</a:t>
             </a:fld>
@@ -5950,7 +5950,7 @@
           <p:cNvPr id="6" name="Footer Placeholder 5">
             <a:extLst>
               <a:ext uri="{FF2B5EF4-FFF2-40B4-BE49-F238E27FC236}">
-                <a16:creationId xmlns:a16="http://schemas.microsoft.com/office/drawing/2014/main" id="{48FD84E3-48E2-FE10-150B-B1798B88A4A7}"/>
+                <a16:creationId xmlns:a16="http://schemas.microsoft.com/office/drawing/2014/main" id="{67D1E917-6538-B221-CDE0-E4F35CC55385}"/>
               </a:ext>
             </a:extLst>
           </p:cNvPr>
@@ -5975,7 +5975,7 @@
           <p:cNvPr id="7" name="Slide Number Placeholder 6">
             <a:extLst>
               <a:ext uri="{FF2B5EF4-FFF2-40B4-BE49-F238E27FC236}">
-                <a16:creationId xmlns:a16="http://schemas.microsoft.com/office/drawing/2014/main" id="{29D70DF5-265B-0719-AAC0-60B9C350C30E}"/>
+                <a16:creationId xmlns:a16="http://schemas.microsoft.com/office/drawing/2014/main" id="{5EA89ACF-013B-D275-45B6-52770FDBBB04}"/>
               </a:ext>
             </a:extLst>
           </p:cNvPr>
@@ -5991,7 +5991,7 @@
           <a:bodyPr/>
           <a:lstStyle/>
           <a:p>
-            <a:fld id="{983EC104-1EB6-4709-99AD-1B097D015398}" type="slidenum">
+            <a:fld id="{C8563E8A-7FC4-4D37-AA23-5DF556F6A4CD}" type="slidenum">
               <a:rPr lang="en-US" smtClean="0"/>
               <a:t>‹#›</a:t>
             </a:fld>
@@ -6002,7 +6002,7 @@
     </p:spTree>
     <p:extLst>
       <p:ext uri="{BB962C8B-B14F-4D97-AF65-F5344CB8AC3E}">
-        <p14:creationId xmlns:p14="http://schemas.microsoft.com/office/powerpoint/2010/main" val="3461151030"/>
+        <p14:creationId xmlns:p14="http://schemas.microsoft.com/office/powerpoint/2010/main" val="4218157537"/>
       </p:ext>
     </p:extLst>
   </p:cSld>
@@ -6034,7 +6034,7 @@
           <p:cNvPr id="2" name="Title 1">
             <a:extLst>
               <a:ext uri="{FF2B5EF4-FFF2-40B4-BE49-F238E27FC236}">
-                <a16:creationId xmlns:a16="http://schemas.microsoft.com/office/drawing/2014/main" id="{652FFDFB-B50F-A986-373F-3A52DB5E08A2}"/>
+                <a16:creationId xmlns:a16="http://schemas.microsoft.com/office/drawing/2014/main" id="{88074C05-5A24-0AFA-EA04-B53180B69B8F}"/>
               </a:ext>
             </a:extLst>
           </p:cNvPr>
@@ -6071,7 +6071,7 @@
           <p:cNvPr id="3" name="Picture Placeholder 2">
             <a:extLst>
               <a:ext uri="{FF2B5EF4-FFF2-40B4-BE49-F238E27FC236}">
-                <a16:creationId xmlns:a16="http://schemas.microsoft.com/office/drawing/2014/main" id="{C42B1B77-4349-4F67-4859-0BBF25527C48}"/>
+                <a16:creationId xmlns:a16="http://schemas.microsoft.com/office/drawing/2014/main" id="{952D13C7-9871-F94E-05A7-D363552336D3}"/>
               </a:ext>
             </a:extLst>
           </p:cNvPr>
@@ -6138,7 +6138,7 @@
           <p:cNvPr id="4" name="Text Placeholder 3">
             <a:extLst>
               <a:ext uri="{FF2B5EF4-FFF2-40B4-BE49-F238E27FC236}">
-                <a16:creationId xmlns:a16="http://schemas.microsoft.com/office/drawing/2014/main" id="{69013A82-D778-8927-99FE-80F5CFFCDD25}"/>
+                <a16:creationId xmlns:a16="http://schemas.microsoft.com/office/drawing/2014/main" id="{A621AF30-919C-9A99-8902-995FFBE255E7}"/>
               </a:ext>
             </a:extLst>
           </p:cNvPr>
@@ -6209,7 +6209,7 @@
           <p:cNvPr id="5" name="Date Placeholder 4">
             <a:extLst>
               <a:ext uri="{FF2B5EF4-FFF2-40B4-BE49-F238E27FC236}">
-                <a16:creationId xmlns:a16="http://schemas.microsoft.com/office/drawing/2014/main" id="{EF8FCE4A-DEBD-4417-D971-21C3F9909B4C}"/>
+                <a16:creationId xmlns:a16="http://schemas.microsoft.com/office/drawing/2014/main" id="{4DE40465-068E-0FBC-96F0-E58843647203}"/>
               </a:ext>
             </a:extLst>
           </p:cNvPr>
@@ -6225,7 +6225,7 @@
           <a:bodyPr/>
           <a:lstStyle/>
           <a:p>
-            <a:fld id="{DD10DBA1-B260-4C9A-B5A0-D8DFDAF8F44C}" type="datetimeFigureOut">
+            <a:fld id="{4CB72EDE-F85A-4F2B-B9E0-665BB0BB45EB}" type="datetimeFigureOut">
               <a:rPr lang="en-US" smtClean="0"/>
               <a:t>2026-07-23</a:t>
             </a:fld>
@@ -6238,7 +6238,7 @@
           <p:cNvPr id="6" name="Footer Placeholder 5">
             <a:extLst>
               <a:ext uri="{FF2B5EF4-FFF2-40B4-BE49-F238E27FC236}">
-                <a16:creationId xmlns:a16="http://schemas.microsoft.com/office/drawing/2014/main" id="{179D6262-A469-B8C7-B570-0C63358027FA}"/>
+                <a16:creationId xmlns:a16="http://schemas.microsoft.com/office/drawing/2014/main" id="{3E0307DA-677E-9A12-5420-923D94B5757E}"/>
               </a:ext>
             </a:extLst>
           </p:cNvPr>
@@ -6263,7 +6263,7 @@
           <p:cNvPr id="7" name="Slide Number Placeholder 6">
             <a:extLst>
               <a:ext uri="{FF2B5EF4-FFF2-40B4-BE49-F238E27FC236}">
-                <a16:creationId xmlns:a16="http://schemas.microsoft.com/office/drawing/2014/main" id="{3DA4D1E1-1EB8-5802-7B08-523D1DAC0726}"/>
+                <a16:creationId xmlns:a16="http://schemas.microsoft.com/office/drawing/2014/main" id="{9AE4EFE3-4E10-75E9-4594-AEE90E8D6647}"/>
               </a:ext>
             </a:extLst>
           </p:cNvPr>
@@ -6279,7 +6279,7 @@
           <a:bodyPr/>
           <a:lstStyle/>
           <a:p>
-            <a:fld id="{983EC104-1EB6-4709-99AD-1B097D015398}" type="slidenum">
+            <a:fld id="{C8563E8A-7FC4-4D37-AA23-5DF556F6A4CD}" type="slidenum">
               <a:rPr lang="en-US" smtClean="0"/>
               <a:t>‹#›</a:t>
             </a:fld>
@@ -6290,7 +6290,7 @@
     </p:spTree>
     <p:extLst>
       <p:ext uri="{BB962C8B-B14F-4D97-AF65-F5344CB8AC3E}">
-        <p14:creationId xmlns:p14="http://schemas.microsoft.com/office/powerpoint/2010/main" val="752836322"/>
+        <p14:creationId xmlns:p14="http://schemas.microsoft.com/office/powerpoint/2010/main" val="2634444668"/>
       </p:ext>
     </p:extLst>
   </p:cSld>
@@ -6327,7 +6327,7 @@
           <p:cNvPr id="2" name="Title Placeholder 1">
             <a:extLst>
               <a:ext uri="{FF2B5EF4-FFF2-40B4-BE49-F238E27FC236}">
-                <a16:creationId xmlns:a16="http://schemas.microsoft.com/office/drawing/2014/main" id="{12709245-03B0-A930-F2B5-116AC2E1CEC5}"/>
+                <a16:creationId xmlns:a16="http://schemas.microsoft.com/office/drawing/2014/main" id="{94037A91-7C8B-B0D8-317F-7DAFE73A56E5}"/>
               </a:ext>
             </a:extLst>
           </p:cNvPr>
@@ -6365,7 +6365,7 @@
           <p:cNvPr id="3" name="Text Placeholder 2">
             <a:extLst>
               <a:ext uri="{FF2B5EF4-FFF2-40B4-BE49-F238E27FC236}">
-                <a16:creationId xmlns:a16="http://schemas.microsoft.com/office/drawing/2014/main" id="{18879BCC-66DD-81D6-BFA0-AF6AC5343ABC}"/>
+                <a16:creationId xmlns:a16="http://schemas.microsoft.com/office/drawing/2014/main" id="{0C0ACB0B-C8FC-5FA9-7186-B7B438A20ED9}"/>
               </a:ext>
             </a:extLst>
           </p:cNvPr>
@@ -6432,7 +6432,7 @@
           <p:cNvPr id="4" name="Date Placeholder 3">
             <a:extLst>
               <a:ext uri="{FF2B5EF4-FFF2-40B4-BE49-F238E27FC236}">
-                <a16:creationId xmlns:a16="http://schemas.microsoft.com/office/drawing/2014/main" id="{CEE540CF-F4B6-300F-1FC7-27935AF1F43F}"/>
+                <a16:creationId xmlns:a16="http://schemas.microsoft.com/office/drawing/2014/main" id="{18C5F6A2-ADBE-82F0-BBC4-D6CA1D06F14B}"/>
               </a:ext>
             </a:extLst>
           </p:cNvPr>
@@ -6466,7 +6466,7 @@
             </a:lvl1pPr>
           </a:lstStyle>
           <a:p>
-            <a:fld id="{DD10DBA1-B260-4C9A-B5A0-D8DFDAF8F44C}" type="datetimeFigureOut">
+            <a:fld id="{4CB72EDE-F85A-4F2B-B9E0-665BB0BB45EB}" type="datetimeFigureOut">
               <a:rPr lang="en-US" smtClean="0"/>
               <a:t>2026-07-23</a:t>
             </a:fld>
@@ -6479,7 +6479,7 @@
           <p:cNvPr id="5" name="Footer Placeholder 4">
             <a:extLst>
               <a:ext uri="{FF2B5EF4-FFF2-40B4-BE49-F238E27FC236}">
-                <a16:creationId xmlns:a16="http://schemas.microsoft.com/office/drawing/2014/main" id="{24F1098F-F97E-00FC-2B2F-D456893F954A}"/>
+                <a16:creationId xmlns:a16="http://schemas.microsoft.com/office/drawing/2014/main" id="{29CCB0D4-1538-BC1D-59D4-30158FFDDCC4}"/>
               </a:ext>
             </a:extLst>
           </p:cNvPr>
@@ -6522,7 +6522,7 @@
           <p:cNvPr id="6" name="Slide Number Placeholder 5">
             <a:extLst>
               <a:ext uri="{FF2B5EF4-FFF2-40B4-BE49-F238E27FC236}">
-                <a16:creationId xmlns:a16="http://schemas.microsoft.com/office/drawing/2014/main" id="{8FF49EFE-0E3E-2027-0FDB-A700E0363363}"/>
+                <a16:creationId xmlns:a16="http://schemas.microsoft.com/office/drawing/2014/main" id="{0F5CE371-59FF-7454-430E-BD0D8E1D3DEC}"/>
               </a:ext>
             </a:extLst>
           </p:cNvPr>
@@ -6556,7 +6556,7 @@
             </a:lvl1pPr>
           </a:lstStyle>
           <a:p>
-            <a:fld id="{983EC104-1EB6-4709-99AD-1B097D015398}" type="slidenum">
+            <a:fld id="{C8563E8A-7FC4-4D37-AA23-5DF556F6A4CD}" type="slidenum">
               <a:rPr lang="en-US" smtClean="0"/>
               <a:t>‹#›</a:t>
             </a:fld>
@@ -6567,7 +6567,7 @@
     </p:spTree>
     <p:extLst>
       <p:ext uri="{BB962C8B-B14F-4D97-AF65-F5344CB8AC3E}">
-        <p14:creationId xmlns:p14="http://schemas.microsoft.com/office/powerpoint/2010/main" val="3840926495"/>
+        <p14:creationId xmlns:p14="http://schemas.microsoft.com/office/powerpoint/2010/main" val="2716096373"/>
       </p:ext>
     </p:extLst>
   </p:cSld>
@@ -6885,12 +6885,47 @@
           <a:chExt cx="0" cy="0"/>
         </a:xfrm>
       </p:grpSpPr>
+      <p:sp>
+        <p:nvSpPr>
+          <p:cNvPr id="2" name="TextBox 1">
+            <a:extLst>
+              <a:ext uri="{FF2B5EF4-FFF2-40B4-BE49-F238E27FC236}">
+                <a16:creationId xmlns:a16="http://schemas.microsoft.com/office/drawing/2014/main" id="{B28BD57D-9C23-BED7-1F09-A0D2336B32F8}"/>
+              </a:ext>
+            </a:extLst>
+          </p:cNvPr>
+          <p:cNvSpPr txBox="1"/>
+          <p:nvPr/>
+        </p:nvSpPr>
+        <p:spPr>
+          <a:xfrm>
+            <a:off x="508000" y="254000"/>
+            <a:ext cx="7620000" cy="461665"/>
+          </a:xfrm>
+          <a:prstGeom prst="rect">
+            <a:avLst/>
+          </a:prstGeom>
+          <a:noFill/>
+        </p:spPr>
+        <p:txBody>
+          <a:bodyPr vert="horz" rtlCol="0">
+            <a:spAutoFit/>
+          </a:bodyPr>
+          <a:lstStyle/>
+          <a:p>
+            <a:r>
+              <a:rPr lang="en-US" sz="2400"/>
+              <a:t>Chart Build Slide</a:t>
+            </a:r>
+          </a:p>
+        </p:txBody>
+      </p:sp>
       <p:graphicFrame>
         <p:nvGraphicFramePr>
-          <p:cNvPr id="2" name="Chart 1">
+          <p:cNvPr id="3" name="Chart 2">
             <a:extLst>
               <a:ext uri="{FF2B5EF4-FFF2-40B4-BE49-F238E27FC236}">
-                <a16:creationId xmlns:a16="http://schemas.microsoft.com/office/drawing/2014/main" id="{3006979E-2588-1578-3328-CA28D152600D}"/>
+                <a16:creationId xmlns:a16="http://schemas.microsoft.com/office/drawing/2014/main" id="{46A47274-25CE-7BA2-931F-F46D76F37AF5}"/>
               </a:ext>
             </a:extLst>
           </p:cNvPr>
@@ -6898,14 +6933,14 @@
           <p:nvPr>
             <p:extLst>
               <p:ext uri="{D42A27DB-BD31-4B8C-83A1-F6EECF244321}">
-                <p14:modId xmlns:p14="http://schemas.microsoft.com/office/powerpoint/2010/main" val="3393886624"/>
+                <p14:modId xmlns:p14="http://schemas.microsoft.com/office/powerpoint/2010/main" val="2451031580"/>
               </p:ext>
             </p:extLst>
           </p:nvPr>
         </p:nvGraphicFramePr>
         <p:xfrm>
-          <a:off x="762000" y="762000"/>
-          <a:ext cx="6604000" cy="4572000"/>
+          <a:off x="762000" y="1143000"/>
+          <a:ext cx="6604000" cy="4191000"/>
         </p:xfrm>
         <a:graphic>
           <a:graphicData uri="http://schemas.openxmlformats.org/drawingml/2006/chart">
@@ -6916,7 +6951,7 @@
     </p:spTree>
     <p:extLst>
       <p:ext uri="{BB962C8B-B14F-4D97-AF65-F5344CB8AC3E}">
-        <p14:creationId xmlns:p14="http://schemas.microsoft.com/office/powerpoint/2010/main" val="2537437519"/>
+        <p14:creationId xmlns:p14="http://schemas.microsoft.com/office/powerpoint/2010/main" val="990887013"/>
       </p:ext>
     </p:extLst>
   </p:cSld>
@@ -6957,7 +6992,7 @@
                                           </p:stCondLst>
                                         </p:cTn>
                                         <p:tgtEl>
-                                          <p:spTgt spid="2"/>
+                                          <p:spTgt spid="3"/>
                                         </p:tgtEl>
                                         <p:attrNameLst>
                                           <p:attrName>style.visibility</p:attrName>
@@ -6971,7 +7006,7 @@
                                       <p:cBhvr>
                                         <p:cTn id="7" dur="500"/>
                                         <p:tgtEl>
-                                          <p:spTgt spid="2"/>
+                                          <p:spTgt spid="3"/>
                                         </p:tgtEl>
                                       </p:cBhvr>
                                     </p:animEffect>
@@ -7006,7 +7041,7 @@
       </p:par>
     </p:tnLst>
     <p:bldLst>
-      <p:bldGraphic spid="2" grpId="0">
+      <p:bldGraphic spid="3" grpId="0">
         <p:bldSub>
           <a:bldChart bld="series"/>
         </p:bldSub>
@@ -7033,12 +7068,47 @@
           <a:chExt cx="0" cy="0"/>
         </a:xfrm>
       </p:grpSpPr>
+      <p:sp>
+        <p:nvSpPr>
+          <p:cNvPr id="2" name="TextBox 1">
+            <a:extLst>
+              <a:ext uri="{FF2B5EF4-FFF2-40B4-BE49-F238E27FC236}">
+                <a16:creationId xmlns:a16="http://schemas.microsoft.com/office/drawing/2014/main" id="{478604B0-6845-5EB1-5AA3-3C37D7B5E11E}"/>
+              </a:ext>
+            </a:extLst>
+          </p:cNvPr>
+          <p:cNvSpPr txBox="1"/>
+          <p:nvPr/>
+        </p:nvSpPr>
+        <p:spPr>
+          <a:xfrm>
+            <a:off x="508000" y="254000"/>
+            <a:ext cx="7620000" cy="461665"/>
+          </a:xfrm>
+          <a:prstGeom prst="rect">
+            <a:avLst/>
+          </a:prstGeom>
+          <a:noFill/>
+        </p:spPr>
+        <p:txBody>
+          <a:bodyPr vert="horz" rtlCol="0">
+            <a:spAutoFit/>
+          </a:bodyPr>
+          <a:lstStyle/>
+          <a:p>
+            <a:r>
+              <a:rPr lang="en-US" sz="2400"/>
+              <a:t>SmartArt Build Slide</a:t>
+            </a:r>
+          </a:p>
+        </p:txBody>
+      </p:sp>
       <p:graphicFrame>
         <p:nvGraphicFramePr>
-          <p:cNvPr id="2" name="Diagram 1">
+          <p:cNvPr id="3" name="Diagram 2">
             <a:extLst>
               <a:ext uri="{FF2B5EF4-FFF2-40B4-BE49-F238E27FC236}">
-                <a16:creationId xmlns:a16="http://schemas.microsoft.com/office/drawing/2014/main" id="{24F53198-E7EE-0890-CA96-2FA4939BCBBD}"/>
+                <a16:creationId xmlns:a16="http://schemas.microsoft.com/office/drawing/2014/main" id="{7820FD47-473C-EEEF-E890-C640494FD115}"/>
               </a:ext>
             </a:extLst>
           </p:cNvPr>
@@ -7046,14 +7116,14 @@
           <p:nvPr>
             <p:extLst>
               <p:ext uri="{D42A27DB-BD31-4B8C-83A1-F6EECF244321}">
-                <p14:modId xmlns:p14="http://schemas.microsoft.com/office/powerpoint/2010/main" val="3340003100"/>
+                <p14:modId xmlns:p14="http://schemas.microsoft.com/office/powerpoint/2010/main" val="2387384684"/>
               </p:ext>
             </p:extLst>
           </p:nvPr>
         </p:nvGraphicFramePr>
         <p:xfrm>
-          <a:off x="762000" y="762000"/>
-          <a:ext cx="6604000" cy="4572000"/>
+          <a:off x="762000" y="1143000"/>
+          <a:ext cx="6604000" cy="4191000"/>
         </p:xfrm>
         <a:graphic>
           <a:graphicData uri="http://schemas.openxmlformats.org/drawingml/2006/diagram">
@@ -7064,7 +7134,7 @@
     </p:spTree>
     <p:extLst>
       <p:ext uri="{BB962C8B-B14F-4D97-AF65-F5344CB8AC3E}">
-        <p14:creationId xmlns:p14="http://schemas.microsoft.com/office/powerpoint/2010/main" val="2820587672"/>
+        <p14:creationId xmlns:p14="http://schemas.microsoft.com/office/powerpoint/2010/main" val="3102212766"/>
       </p:ext>
     </p:extLst>
   </p:cSld>
@@ -7105,7 +7175,7 @@
                                           </p:stCondLst>
                                         </p:cTn>
                                         <p:tgtEl>
-                                          <p:spTgt spid="2"/>
+                                          <p:spTgt spid="3"/>
                                         </p:tgtEl>
                                         <p:attrNameLst>
                                           <p:attrName>style.visibility</p:attrName>
@@ -7119,7 +7189,7 @@
                                       <p:cBhvr>
                                         <p:cTn id="7" dur="500"/>
                                         <p:tgtEl>
-                                          <p:spTgt spid="2"/>
+                                          <p:spTgt spid="3"/>
                                         </p:tgtEl>
                                       </p:cBhvr>
                                     </p:animEffect>
@@ -7154,7 +7224,7 @@
       </p:par>
     </p:tnLst>
     <p:bldLst>
-      <p:bldGraphic spid="2" grpId="0">
+      <p:bldGraphic spid="3" grpId="0">
         <p:bldSub>
           <a:bldDgm bld="one"/>
         </p:bldSub>
@@ -7183,10 +7253,45 @@
       </p:grpSpPr>
       <p:sp>
         <p:nvSpPr>
-          <p:cNvPr id="2" name="Rectangle 1">
+          <p:cNvPr id="2" name="TextBox 1">
             <a:extLst>
               <a:ext uri="{FF2B5EF4-FFF2-40B4-BE49-F238E27FC236}">
-                <a16:creationId xmlns:a16="http://schemas.microsoft.com/office/drawing/2014/main" id="{36EB8125-08BE-1FAA-0715-9620D91E0ADE}"/>
+                <a16:creationId xmlns:a16="http://schemas.microsoft.com/office/drawing/2014/main" id="{5FD2AF8A-3969-2583-204B-CA0DD049DE56}"/>
+              </a:ext>
+            </a:extLst>
+          </p:cNvPr>
+          <p:cNvSpPr txBox="1"/>
+          <p:nvPr/>
+        </p:nvSpPr>
+        <p:spPr>
+          <a:xfrm>
+            <a:off x="508000" y="254000"/>
+            <a:ext cx="7620000" cy="461665"/>
+          </a:xfrm>
+          <a:prstGeom prst="rect">
+            <a:avLst/>
+          </a:prstGeom>
+          <a:noFill/>
+        </p:spPr>
+        <p:txBody>
+          <a:bodyPr vert="horz" rtlCol="0">
+            <a:spAutoFit/>
+          </a:bodyPr>
+          <a:lstStyle/>
+          <a:p>
+            <a:r>
+              <a:rPr lang="en-US" sz="2400"/>
+              <a:t>Color Emphasis Slide</a:t>
+            </a:r>
+          </a:p>
+        </p:txBody>
+      </p:sp>
+      <p:sp>
+        <p:nvSpPr>
+          <p:cNvPr id="3" name="Rectangle 2">
+            <a:extLst>
+              <a:ext uri="{FF2B5EF4-FFF2-40B4-BE49-F238E27FC236}">
+                <a16:creationId xmlns:a16="http://schemas.microsoft.com/office/drawing/2014/main" id="{CB7AB468-896D-8EDF-4550-B7ACC4A98F11}"/>
               </a:ext>
             </a:extLst>
           </p:cNvPr>
@@ -7195,8 +7300,8 @@
         </p:nvSpPr>
         <p:spPr>
           <a:xfrm>
-            <a:off x="2032000" y="1778000"/>
-            <a:ext cx="4064000" cy="3048000"/>
+            <a:off x="2286000" y="1905000"/>
+            <a:ext cx="4064000" cy="2794000"/>
           </a:xfrm>
           <a:prstGeom prst="rect">
             <a:avLst/>
@@ -7226,14 +7331,17 @@
           <a:lstStyle/>
           <a:p>
             <a:pPr algn="ctr"/>
-            <a:endParaRPr lang="en-US"/>
+            <a:r>
+              <a:rPr lang="en-US" sz="2800"/>
+              <a:t>COLOR ME</a:t>
+            </a:r>
           </a:p>
         </p:txBody>
       </p:sp>
     </p:spTree>
     <p:extLst>
       <p:ext uri="{BB962C8B-B14F-4D97-AF65-F5344CB8AC3E}">
-        <p14:creationId xmlns:p14="http://schemas.microsoft.com/office/powerpoint/2010/main" val="2285258094"/>
+        <p14:creationId xmlns:p14="http://schemas.microsoft.com/office/powerpoint/2010/main" val="1063420065"/>
       </p:ext>
     </p:extLst>
   </p:cSld>
@@ -7270,7 +7378,7 @@
                                       <p:cBhvr>
                                         <p:cTn id="6" dur="2000" fill="hold"/>
                                         <p:tgtEl>
-                                          <p:spTgt spid="2"/>
+                                          <p:spTgt spid="3"/>
                                         </p:tgtEl>
                                         <p:attrNameLst>
                                           <p:attrName>fillcolor</p:attrName>
@@ -7284,7 +7392,7 @@
                                       <p:cBhvr>
                                         <p:cTn id="7" dur="2000" fill="hold"/>
                                         <p:tgtEl>
-                                          <p:spTgt spid="2"/>
+                                          <p:spTgt spid="3"/>
                                         </p:tgtEl>
                                         <p:attrNameLst>
                                           <p:attrName>fill.type</p:attrName>
@@ -7298,7 +7406,7 @@
                                       <p:cBhvr>
                                         <p:cTn id="8" dur="2000" fill="hold"/>
                                         <p:tgtEl>
-                                          <p:spTgt spid="2"/>
+                                          <p:spTgt spid="3"/>
                                         </p:tgtEl>
                                         <p:attrNameLst>
                                           <p:attrName>fill.on</p:attrName>

</xml_diff>